<commit_message>
Implement feature X to enhance user experience and fix bug Y in module Z
</commit_message>
<xml_diff>
--- a/docs/academic/TeslimEdilecekler/Sunumlar/01_Donem_Baslangic_Sunumu.pptx
+++ b/docs/academic/TeslimEdilecekler/Sunumlar/01_Donem_Baslangic_Sunumu.pptx
@@ -3109,7 +3109,7 @@
         <p:spPr>
           <a:xfrm>
             <a:off x="0" y="0"/>
-            <a:ext cx="12188952" cy="1417320"/>
+            <a:ext cx="12188952" cy="2468880"/>
           </a:xfrm>
           <a:prstGeom prst="rect">
             <a:avLst/>
@@ -3145,14 +3145,57 @@
       </p:sp>
       <p:sp>
         <p:nvSpPr>
-          <p:cNvPr id="3" name="TextBox 2"/>
+          <p:cNvPr id="3" name="Rectangle 2"/>
+          <p:cNvSpPr/>
+          <p:nvPr/>
+        </p:nvSpPr>
+        <p:spPr>
+          <a:xfrm>
+            <a:off x="0" y="2468880"/>
+            <a:ext cx="12188952" cy="64008"/>
+          </a:xfrm>
+          <a:prstGeom prst="rect">
+            <a:avLst/>
+          </a:prstGeom>
+          <a:solidFill>
+            <a:srgbClr val="E0A800"/>
+          </a:solidFill>
+          <a:ln>
+            <a:noFill/>
+          </a:ln>
+        </p:spPr>
+        <p:style>
+          <a:lnRef idx="1">
+            <a:schemeClr val="accent1"/>
+          </a:lnRef>
+          <a:fillRef idx="3">
+            <a:schemeClr val="accent1"/>
+          </a:fillRef>
+          <a:effectRef idx="2">
+            <a:schemeClr val="accent1"/>
+          </a:effectRef>
+          <a:fontRef idx="minor">
+            <a:schemeClr val="lt1"/>
+          </a:fontRef>
+        </p:style>
+        <p:txBody>
+          <a:bodyPr rtlCol="0" anchor="ctr"/>
+          <a:lstStyle/>
+          <a:p>
+            <a:pPr algn="ctr"/>
+          </a:p>
+        </p:txBody>
+      </p:sp>
+      <p:sp>
+        <p:nvSpPr>
+          <p:cNvPr id="4" name="TextBox 3"/>
           <p:cNvSpPr txBox="1"/>
           <p:nvPr/>
         </p:nvSpPr>
         <p:spPr>
           <a:xfrm>
-            <a:off x="320040" y="91440"/>
-            <a:ext cx="11521440" cy="822960"/>
+            <a:off x="548640" y="411480"/>
+            <a:ext cx="10972800" cy="365760"/>
           </a:xfrm>
           <a:prstGeom prst="rect">
             <a:avLst/>
@@ -3167,26 +3210,26 @@
           <a:p>
             <a:pPr algn="l"/>
             <a:r>
-              <a:rPr sz="2500" b="1">
-                <a:solidFill>
-                  <a:srgbClr val="FFFFFF"/>
-                </a:solidFill>
-              </a:rPr>
-              <a:t>01 — Dönem Başlangıç Sunumu</a:t>
-            </a:r>
-          </a:p>
-        </p:txBody>
-      </p:sp>
-      <p:sp>
-        <p:nvSpPr>
-          <p:cNvPr id="4" name="TextBox 3"/>
+              <a:rPr sz="1300" b="1" i="0">
+                <a:solidFill>
+                  <a:srgbClr val="E0A800"/>
+                </a:solidFill>
+              </a:rPr>
+              <a:t>01 — DÖNEM BAŞLANGIÇ SUNUMU</a:t>
+            </a:r>
+          </a:p>
+        </p:txBody>
+      </p:sp>
+      <p:sp>
+        <p:nvSpPr>
+          <p:cNvPr id="5" name="TextBox 4"/>
           <p:cNvSpPr txBox="1"/>
           <p:nvPr/>
         </p:nvSpPr>
         <p:spPr>
           <a:xfrm>
-            <a:off x="320040" y="841248"/>
-            <a:ext cx="11521440" cy="457200"/>
+            <a:off x="548640" y="868680"/>
+            <a:ext cx="10972800" cy="914400"/>
           </a:xfrm>
           <a:prstGeom prst="rect">
             <a:avLst/>
@@ -3201,26 +3244,60 @@
           <a:p>
             <a:pPr algn="l"/>
             <a:r>
-              <a:rPr sz="1200" b="0">
-                <a:solidFill>
-                  <a:srgbClr val="B0C8D8"/>
-                </a:solidFill>
-              </a:rPr>
-              <a:t>BM498 | 2025-2026 Güz Dönemi</a:t>
-            </a:r>
-          </a:p>
-        </p:txBody>
-      </p:sp>
-      <p:sp>
-        <p:nvSpPr>
-          <p:cNvPr id="5" name="TextBox 4"/>
+              <a:rPr sz="3400" b="1" i="0">
+                <a:solidFill>
+                  <a:srgbClr val="FFFFFF"/>
+                </a:solidFill>
+              </a:rPr>
+              <a:t>AURIS Proje Önerisi</a:t>
+            </a:r>
+          </a:p>
+        </p:txBody>
+      </p:sp>
+      <p:sp>
+        <p:nvSpPr>
+          <p:cNvPr id="6" name="TextBox 5"/>
           <p:cNvSpPr txBox="1"/>
           <p:nvPr/>
         </p:nvSpPr>
         <p:spPr>
           <a:xfrm>
-            <a:off x="457200" y="1554480"/>
-            <a:ext cx="11247120" cy="4572000"/>
+            <a:off x="548640" y="1691640"/>
+            <a:ext cx="10972800" cy="548640"/>
+          </a:xfrm>
+          <a:prstGeom prst="rect">
+            <a:avLst/>
+          </a:prstGeom>
+          <a:noFill/>
+        </p:spPr>
+        <p:txBody>
+          <a:bodyPr wrap="square">
+            <a:spAutoFit/>
+          </a:bodyPr>
+          <a:lstStyle/>
+          <a:p>
+            <a:pPr algn="l"/>
+            <a:r>
+              <a:rPr sz="1600" b="0" i="0">
+                <a:solidFill>
+                  <a:srgbClr val="AEC6D6"/>
+                </a:solidFill>
+              </a:rPr>
+              <a:t>Yapay Zekâ Üretimli Müzik Tespitinde Topluluk Öğrenmesi</a:t>
+            </a:r>
+          </a:p>
+        </p:txBody>
+      </p:sp>
+      <p:sp>
+        <p:nvSpPr>
+          <p:cNvPr id="7" name="TextBox 6"/>
+          <p:cNvSpPr txBox="1"/>
+          <p:nvPr/>
+        </p:nvSpPr>
+        <p:spPr>
+          <a:xfrm>
+            <a:off x="640080" y="2926080"/>
+            <a:ext cx="6949440" cy="3474720"/>
           </a:xfrm>
           <a:prstGeom prst="rect">
             <a:avLst/>
@@ -3239,12 +3316,12 @@
               </a:spcAft>
             </a:pPr>
             <a:r>
-              <a:rPr sz="1500">
-                <a:solidFill>
-                  <a:srgbClr val="333333"/>
-                </a:solidFill>
-              </a:rPr>
-              <a:t>Proje Adı :   AURIS — Yapay Zekâ Üretimli Müzik Tespitinde Topluluk Öğrenmesi</a:t>
+              <a:rPr sz="1400">
+                <a:solidFill>
+                  <a:srgbClr val="2A2A2A"/>
+                </a:solidFill>
+              </a:rPr>
+              <a:t>Problem: Üretken YZ sistemleri (Suno, Udio, MusicGen) insan kaydından</a:t>
             </a:r>
           </a:p>
           <a:p>
@@ -3254,12 +3331,12 @@
               </a:spcAft>
             </a:pPr>
             <a:r>
-              <a:rPr sz="1500">
-                <a:solidFill>
-                  <a:srgbClr val="333333"/>
-                </a:solidFill>
-              </a:rPr>
-              <a:t>Öğrenci   :   Hasan Arthur Altuntaş</a:t>
+              <a:rPr sz="1400">
+                <a:solidFill>
+                  <a:srgbClr val="2A2A2A"/>
+                </a:solidFill>
+              </a:rPr>
+              <a:t>ayırt edilemeyen müzik üretiyor; otomatik tespit yöntemi gerekiyor.</a:t>
             </a:r>
           </a:p>
           <a:p>
@@ -3269,12 +3346,12 @@
               </a:spcAft>
             </a:pPr>
             <a:r>
-              <a:rPr sz="1500">
-                <a:solidFill>
-                  <a:srgbClr val="333333"/>
-                </a:solidFill>
-              </a:rPr>
-              <a:t>Danışman  :   ___________________________</a:t>
+              <a:rPr sz="1400">
+                <a:solidFill>
+                  <a:srgbClr val="2A2A2A"/>
+                </a:solidFill>
+              </a:rPr>
+              <a:t/>
             </a:r>
           </a:p>
           <a:p>
@@ -3284,12 +3361,12 @@
               </a:spcAft>
             </a:pPr>
             <a:r>
-              <a:rPr sz="1500">
-                <a:solidFill>
-                  <a:srgbClr val="333333"/>
-                </a:solidFill>
-              </a:rPr>
-              <a:t/>
+              <a:rPr sz="1400">
+                <a:solidFill>
+                  <a:srgbClr val="2A2A2A"/>
+                </a:solidFill>
+              </a:rPr>
+              <a:t>Amaç: %90+ ROC-AUC ile sınıflandırma yapan, açıklanabilir, hafif bir</a:t>
             </a:r>
           </a:p>
           <a:p>
@@ -3299,12 +3376,12 @@
               </a:spcAft>
             </a:pPr>
             <a:r>
-              <a:rPr sz="1500">
-                <a:solidFill>
-                  <a:srgbClr val="333333"/>
-                </a:solidFill>
-              </a:rPr>
-              <a:t>Problem   :   Suno, Udio, MusicGen gibi sistemlerin ürettiği müziği</a:t>
+              <a:rPr sz="1400">
+                <a:solidFill>
+                  <a:srgbClr val="2A2A2A"/>
+                </a:solidFill>
+              </a:rPr>
+              <a:t>tespit sistemi geliştirmek.</a:t>
             </a:r>
           </a:p>
           <a:p>
@@ -3314,12 +3391,12 @@
               </a:spcAft>
             </a:pPr>
             <a:r>
-              <a:rPr sz="1500">
-                <a:solidFill>
-                  <a:srgbClr val="333333"/>
-                </a:solidFill>
-              </a:rPr>
-              <a:t>               insan kayıtlarından otomatik olarak ayırt etmek.</a:t>
+              <a:rPr sz="1400">
+                <a:solidFill>
+                  <a:srgbClr val="2A2A2A"/>
+                </a:solidFill>
+              </a:rPr>
+              <a:t/>
             </a:r>
           </a:p>
           <a:p>
@@ -3329,12 +3406,12 @@
               </a:spcAft>
             </a:pPr>
             <a:r>
-              <a:rPr sz="1500">
-                <a:solidFill>
-                  <a:srgbClr val="333333"/>
-                </a:solidFill>
-              </a:rPr>
-              <a:t/>
+              <a:rPr sz="1400">
+                <a:solidFill>
+                  <a:srgbClr val="2A2A2A"/>
+                </a:solidFill>
+              </a:rPr>
+              <a:t>Yaklaşım: 47 boyutlu elle tasarlanmış akustik öznitelik vektörü +</a:t>
             </a:r>
           </a:p>
           <a:p>
@@ -3344,56 +3421,69 @@
               </a:spcAft>
             </a:pPr>
             <a:r>
-              <a:rPr sz="1500">
-                <a:solidFill>
-                  <a:srgbClr val="333333"/>
-                </a:solidFill>
-              </a:rPr>
-              <a:t>Hedef     :   %90+ ROC-AUC, 47 boyutlu öznitelik, açıklanabilir model.</a:t>
-            </a:r>
-          </a:p>
-          <a:p>
-            <a:pPr>
-              <a:spcAft>
-                <a:spcPts val="400"/>
-              </a:spcAft>
-            </a:pPr>
-            <a:r>
-              <a:rPr sz="1500">
-                <a:solidFill>
-                  <a:srgbClr val="333333"/>
-                </a:solidFill>
-              </a:rPr>
-              <a:t/>
-            </a:r>
-          </a:p>
-          <a:p>
-            <a:pPr>
-              <a:spcAft>
-                <a:spcPts val="400"/>
-              </a:spcAft>
-            </a:pPr>
-            <a:r>
-              <a:rPr sz="1500">
-                <a:solidFill>
-                  <a:srgbClr val="333333"/>
-                </a:solidFill>
-              </a:rPr>
-              <a:t>Kapsam    :   5.195 ses örneği, çoklu kaynak, 11 sınıflandırma modeli.</a:t>
-            </a:r>
-          </a:p>
-        </p:txBody>
-      </p:sp>
-      <p:sp>
-        <p:nvSpPr>
-          <p:cNvPr id="6" name="TextBox 5"/>
+              <a:rPr sz="1400">
+                <a:solidFill>
+                  <a:srgbClr val="2A2A2A"/>
+                </a:solidFill>
+              </a:rPr>
+              <a:t>11 modelden oluşan topluluk öğrenmesi.</a:t>
+            </a:r>
+          </a:p>
+        </p:txBody>
+      </p:sp>
+      <p:sp>
+        <p:nvSpPr>
+          <p:cNvPr id="8" name="Rectangle 7"/>
+          <p:cNvSpPr/>
+          <p:nvPr/>
+        </p:nvSpPr>
+        <p:spPr>
+          <a:xfrm>
+            <a:off x="7955279" y="2971800"/>
+            <a:ext cx="3749039" cy="960120"/>
+          </a:xfrm>
+          <a:prstGeom prst="rect">
+            <a:avLst/>
+          </a:prstGeom>
+          <a:solidFill>
+            <a:srgbClr val="0D2B55"/>
+          </a:solidFill>
+          <a:ln>
+            <a:noFill/>
+          </a:ln>
+        </p:spPr>
+        <p:style>
+          <a:lnRef idx="1">
+            <a:schemeClr val="accent1"/>
+          </a:lnRef>
+          <a:fillRef idx="3">
+            <a:schemeClr val="accent1"/>
+          </a:fillRef>
+          <a:effectRef idx="2">
+            <a:schemeClr val="accent1"/>
+          </a:effectRef>
+          <a:fontRef idx="minor">
+            <a:schemeClr val="lt1"/>
+          </a:fontRef>
+        </p:style>
+        <p:txBody>
+          <a:bodyPr rtlCol="0" anchor="ctr"/>
+          <a:lstStyle/>
+          <a:p>
+            <a:pPr algn="ctr"/>
+          </a:p>
+        </p:txBody>
+      </p:sp>
+      <p:sp>
+        <p:nvSpPr>
+          <p:cNvPr id="9" name="TextBox 8"/>
           <p:cNvSpPr txBox="1"/>
           <p:nvPr/>
         </p:nvSpPr>
         <p:spPr>
           <a:xfrm>
-            <a:off x="0" y="6510528"/>
-            <a:ext cx="12188952" cy="301752"/>
+            <a:off x="7955279" y="3096615"/>
+            <a:ext cx="3749039" cy="480060"/>
           </a:xfrm>
           <a:prstGeom prst="rect">
             <a:avLst/>
@@ -3408,12 +3498,336 @@
           <a:p>
             <a:pPr algn="ctr"/>
             <a:r>
-              <a:rPr sz="900" b="0">
-                <a:solidFill>
-                  <a:srgbClr val="8899AA"/>
-                </a:solidFill>
-              </a:rPr>
-              <a:t>Hasan Arthur Altuntaş  |  BM498  |  Düzce Üniversitesi  |  2025-2026</a:t>
+              <a:rPr sz="2600" b="1" i="0">
+                <a:solidFill>
+                  <a:srgbClr val="E0A800"/>
+                </a:solidFill>
+              </a:rPr>
+              <a:t>5.195</a:t>
+            </a:r>
+          </a:p>
+        </p:txBody>
+      </p:sp>
+      <p:sp>
+        <p:nvSpPr>
+          <p:cNvPr id="10" name="TextBox 9"/>
+          <p:cNvSpPr txBox="1"/>
+          <p:nvPr/>
+        </p:nvSpPr>
+        <p:spPr>
+          <a:xfrm>
+            <a:off x="7955279" y="3567074"/>
+            <a:ext cx="3749039" cy="307238"/>
+          </a:xfrm>
+          <a:prstGeom prst="rect">
+            <a:avLst/>
+          </a:prstGeom>
+          <a:noFill/>
+        </p:spPr>
+        <p:txBody>
+          <a:bodyPr wrap="square">
+            <a:spAutoFit/>
+          </a:bodyPr>
+          <a:lstStyle/>
+          <a:p>
+            <a:pPr algn="ctr"/>
+            <a:r>
+              <a:rPr sz="1100" b="0" i="0">
+                <a:solidFill>
+                  <a:srgbClr val="FFFFFF"/>
+                </a:solidFill>
+              </a:rPr>
+              <a:t>Ses örneği</a:t>
+            </a:r>
+          </a:p>
+        </p:txBody>
+      </p:sp>
+      <p:sp>
+        <p:nvSpPr>
+          <p:cNvPr id="11" name="Rectangle 10"/>
+          <p:cNvSpPr/>
+          <p:nvPr/>
+        </p:nvSpPr>
+        <p:spPr>
+          <a:xfrm>
+            <a:off x="7955279" y="4069080"/>
+            <a:ext cx="3749039" cy="960120"/>
+          </a:xfrm>
+          <a:prstGeom prst="rect">
+            <a:avLst/>
+          </a:prstGeom>
+          <a:solidFill>
+            <a:srgbClr val="0D2B55"/>
+          </a:solidFill>
+          <a:ln>
+            <a:noFill/>
+          </a:ln>
+        </p:spPr>
+        <p:style>
+          <a:lnRef idx="1">
+            <a:schemeClr val="accent1"/>
+          </a:lnRef>
+          <a:fillRef idx="3">
+            <a:schemeClr val="accent1"/>
+          </a:fillRef>
+          <a:effectRef idx="2">
+            <a:schemeClr val="accent1"/>
+          </a:effectRef>
+          <a:fontRef idx="minor">
+            <a:schemeClr val="lt1"/>
+          </a:fontRef>
+        </p:style>
+        <p:txBody>
+          <a:bodyPr rtlCol="0" anchor="ctr"/>
+          <a:lstStyle/>
+          <a:p>
+            <a:pPr algn="ctr"/>
+          </a:p>
+        </p:txBody>
+      </p:sp>
+      <p:sp>
+        <p:nvSpPr>
+          <p:cNvPr id="12" name="TextBox 11"/>
+          <p:cNvSpPr txBox="1"/>
+          <p:nvPr/>
+        </p:nvSpPr>
+        <p:spPr>
+          <a:xfrm>
+            <a:off x="7955279" y="4193895"/>
+            <a:ext cx="3749039" cy="480060"/>
+          </a:xfrm>
+          <a:prstGeom prst="rect">
+            <a:avLst/>
+          </a:prstGeom>
+          <a:noFill/>
+        </p:spPr>
+        <p:txBody>
+          <a:bodyPr wrap="square">
+            <a:spAutoFit/>
+          </a:bodyPr>
+          <a:lstStyle/>
+          <a:p>
+            <a:pPr algn="ctr"/>
+            <a:r>
+              <a:rPr sz="2600" b="1" i="0">
+                <a:solidFill>
+                  <a:srgbClr val="E0A800"/>
+                </a:solidFill>
+              </a:rPr>
+              <a:t>47</a:t>
+            </a:r>
+          </a:p>
+        </p:txBody>
+      </p:sp>
+      <p:sp>
+        <p:nvSpPr>
+          <p:cNvPr id="13" name="TextBox 12"/>
+          <p:cNvSpPr txBox="1"/>
+          <p:nvPr/>
+        </p:nvSpPr>
+        <p:spPr>
+          <a:xfrm>
+            <a:off x="7955279" y="4664354"/>
+            <a:ext cx="3749039" cy="307238"/>
+          </a:xfrm>
+          <a:prstGeom prst="rect">
+            <a:avLst/>
+          </a:prstGeom>
+          <a:noFill/>
+        </p:spPr>
+        <p:txBody>
+          <a:bodyPr wrap="square">
+            <a:spAutoFit/>
+          </a:bodyPr>
+          <a:lstStyle/>
+          <a:p>
+            <a:pPr algn="ctr"/>
+            <a:r>
+              <a:rPr sz="1100" b="0" i="0">
+                <a:solidFill>
+                  <a:srgbClr val="FFFFFF"/>
+                </a:solidFill>
+              </a:rPr>
+              <a:t>Akustik öznitelik</a:t>
+            </a:r>
+          </a:p>
+        </p:txBody>
+      </p:sp>
+      <p:sp>
+        <p:nvSpPr>
+          <p:cNvPr id="14" name="Rectangle 13"/>
+          <p:cNvSpPr/>
+          <p:nvPr/>
+        </p:nvSpPr>
+        <p:spPr>
+          <a:xfrm>
+            <a:off x="7955279" y="5166360"/>
+            <a:ext cx="3749039" cy="960120"/>
+          </a:xfrm>
+          <a:prstGeom prst="rect">
+            <a:avLst/>
+          </a:prstGeom>
+          <a:solidFill>
+            <a:srgbClr val="0D2B55"/>
+          </a:solidFill>
+          <a:ln>
+            <a:noFill/>
+          </a:ln>
+        </p:spPr>
+        <p:style>
+          <a:lnRef idx="1">
+            <a:schemeClr val="accent1"/>
+          </a:lnRef>
+          <a:fillRef idx="3">
+            <a:schemeClr val="accent1"/>
+          </a:fillRef>
+          <a:effectRef idx="2">
+            <a:schemeClr val="accent1"/>
+          </a:effectRef>
+          <a:fontRef idx="minor">
+            <a:schemeClr val="lt1"/>
+          </a:fontRef>
+        </p:style>
+        <p:txBody>
+          <a:bodyPr rtlCol="0" anchor="ctr"/>
+          <a:lstStyle/>
+          <a:p>
+            <a:pPr algn="ctr"/>
+          </a:p>
+        </p:txBody>
+      </p:sp>
+      <p:sp>
+        <p:nvSpPr>
+          <p:cNvPr id="15" name="TextBox 14"/>
+          <p:cNvSpPr txBox="1"/>
+          <p:nvPr/>
+        </p:nvSpPr>
+        <p:spPr>
+          <a:xfrm>
+            <a:off x="7955279" y="5291175"/>
+            <a:ext cx="3749039" cy="480060"/>
+          </a:xfrm>
+          <a:prstGeom prst="rect">
+            <a:avLst/>
+          </a:prstGeom>
+          <a:noFill/>
+        </p:spPr>
+        <p:txBody>
+          <a:bodyPr wrap="square">
+            <a:spAutoFit/>
+          </a:bodyPr>
+          <a:lstStyle/>
+          <a:p>
+            <a:pPr algn="ctr"/>
+            <a:r>
+              <a:rPr sz="2600" b="1" i="0">
+                <a:solidFill>
+                  <a:srgbClr val="E0A800"/>
+                </a:solidFill>
+              </a:rPr>
+              <a:t>11</a:t>
+            </a:r>
+          </a:p>
+        </p:txBody>
+      </p:sp>
+      <p:sp>
+        <p:nvSpPr>
+          <p:cNvPr id="16" name="TextBox 15"/>
+          <p:cNvSpPr txBox="1"/>
+          <p:nvPr/>
+        </p:nvSpPr>
+        <p:spPr>
+          <a:xfrm>
+            <a:off x="7955279" y="5761634"/>
+            <a:ext cx="3749039" cy="307238"/>
+          </a:xfrm>
+          <a:prstGeom prst="rect">
+            <a:avLst/>
+          </a:prstGeom>
+          <a:noFill/>
+        </p:spPr>
+        <p:txBody>
+          <a:bodyPr wrap="square">
+            <a:spAutoFit/>
+          </a:bodyPr>
+          <a:lstStyle/>
+          <a:p>
+            <a:pPr algn="ctr"/>
+            <a:r>
+              <a:rPr sz="1100" b="0" i="0">
+                <a:solidFill>
+                  <a:srgbClr val="FFFFFF"/>
+                </a:solidFill>
+              </a:rPr>
+              <a:t>Sınıflandırma modeli</a:t>
+            </a:r>
+          </a:p>
+        </p:txBody>
+      </p:sp>
+      <p:sp>
+        <p:nvSpPr>
+          <p:cNvPr id="17" name="TextBox 16"/>
+          <p:cNvSpPr txBox="1"/>
+          <p:nvPr/>
+        </p:nvSpPr>
+        <p:spPr>
+          <a:xfrm>
+            <a:off x="365760" y="6510528"/>
+            <a:ext cx="8229600" cy="301752"/>
+          </a:xfrm>
+          <a:prstGeom prst="rect">
+            <a:avLst/>
+          </a:prstGeom>
+          <a:noFill/>
+        </p:spPr>
+        <p:txBody>
+          <a:bodyPr wrap="square">
+            <a:spAutoFit/>
+          </a:bodyPr>
+          <a:lstStyle/>
+          <a:p>
+            <a:pPr algn="l"/>
+            <a:r>
+              <a:rPr sz="900" b="0" i="0">
+                <a:solidFill>
+                  <a:srgbClr val="66707A"/>
+                </a:solidFill>
+              </a:rPr>
+              <a:t>AURIS  ·  Hasan Arthur Altuntaş  ·  BM498 Mezuniyet Tezi</a:t>
+            </a:r>
+          </a:p>
+        </p:txBody>
+      </p:sp>
+      <p:sp>
+        <p:nvSpPr>
+          <p:cNvPr id="18" name="TextBox 17"/>
+          <p:cNvSpPr txBox="1"/>
+          <p:nvPr/>
+        </p:nvSpPr>
+        <p:spPr>
+          <a:xfrm>
+            <a:off x="8595360" y="6510528"/>
+            <a:ext cx="3200400" cy="301752"/>
+          </a:xfrm>
+          <a:prstGeom prst="rect">
+            <a:avLst/>
+          </a:prstGeom>
+          <a:noFill/>
+        </p:spPr>
+        <p:txBody>
+          <a:bodyPr wrap="square">
+            <a:spAutoFit/>
+          </a:bodyPr>
+          <a:lstStyle/>
+          <a:p>
+            <a:pPr algn="r"/>
+            <a:r>
+              <a:rPr sz="900" b="0" i="0">
+                <a:solidFill>
+                  <a:srgbClr val="66707A"/>
+                </a:solidFill>
+              </a:rPr>
+              <a:t>Düzce Üniversitesi · 2025-2026</a:t>
             </a:r>
           </a:p>
         </p:txBody>
@@ -3453,7 +3867,7 @@
         <p:spPr>
           <a:xfrm>
             <a:off x="0" y="0"/>
-            <a:ext cx="12188952" cy="1417320"/>
+            <a:ext cx="12188952" cy="1371600"/>
           </a:xfrm>
           <a:prstGeom prst="rect">
             <a:avLst/>
@@ -3489,14 +3903,57 @@
       </p:sp>
       <p:sp>
         <p:nvSpPr>
-          <p:cNvPr id="3" name="TextBox 2"/>
+          <p:cNvPr id="3" name="Rectangle 2"/>
+          <p:cNvSpPr/>
+          <p:nvPr/>
+        </p:nvSpPr>
+        <p:spPr>
+          <a:xfrm>
+            <a:off x="0" y="1371600"/>
+            <a:ext cx="12188952" cy="54864"/>
+          </a:xfrm>
+          <a:prstGeom prst="rect">
+            <a:avLst/>
+          </a:prstGeom>
+          <a:solidFill>
+            <a:srgbClr val="E0A800"/>
+          </a:solidFill>
+          <a:ln>
+            <a:noFill/>
+          </a:ln>
+        </p:spPr>
+        <p:style>
+          <a:lnRef idx="1">
+            <a:schemeClr val="accent1"/>
+          </a:lnRef>
+          <a:fillRef idx="3">
+            <a:schemeClr val="accent1"/>
+          </a:fillRef>
+          <a:effectRef idx="2">
+            <a:schemeClr val="accent1"/>
+          </a:effectRef>
+          <a:fontRef idx="minor">
+            <a:schemeClr val="lt1"/>
+          </a:fontRef>
+        </p:style>
+        <p:txBody>
+          <a:bodyPr rtlCol="0" anchor="ctr"/>
+          <a:lstStyle/>
+          <a:p>
+            <a:pPr algn="ctr"/>
+          </a:p>
+        </p:txBody>
+      </p:sp>
+      <p:sp>
+        <p:nvSpPr>
+          <p:cNvPr id="4" name="TextBox 3"/>
           <p:cNvSpPr txBox="1"/>
           <p:nvPr/>
         </p:nvSpPr>
         <p:spPr>
           <a:xfrm>
-            <a:off x="320040" y="91440"/>
-            <a:ext cx="11521440" cy="822960"/>
+            <a:off x="365760" y="109728"/>
+            <a:ext cx="11430000" cy="320040"/>
           </a:xfrm>
           <a:prstGeom prst="rect">
             <a:avLst/>
@@ -3511,26 +3968,26 @@
           <a:p>
             <a:pPr algn="l"/>
             <a:r>
-              <a:rPr sz="2500" b="1">
-                <a:solidFill>
-                  <a:srgbClr val="FFFFFF"/>
-                </a:solidFill>
-              </a:rPr>
-              <a:t>Problem Tanımı ve Motivasyon</a:t>
-            </a:r>
-          </a:p>
-        </p:txBody>
-      </p:sp>
-      <p:sp>
-        <p:nvSpPr>
-          <p:cNvPr id="4" name="TextBox 3"/>
+              <a:rPr sz="1100" b="1" i="0">
+                <a:solidFill>
+                  <a:srgbClr val="E0A800"/>
+                </a:solidFill>
+              </a:rPr>
+              <a:t>BÖLÜM 1 · GIRIŞ</a:t>
+            </a:r>
+          </a:p>
+        </p:txBody>
+      </p:sp>
+      <p:sp>
+        <p:nvSpPr>
+          <p:cNvPr id="5" name="TextBox 4"/>
           <p:cNvSpPr txBox="1"/>
           <p:nvPr/>
         </p:nvSpPr>
         <p:spPr>
           <a:xfrm>
-            <a:off x="457200" y="1554480"/>
-            <a:ext cx="11247120" cy="4754880"/>
+            <a:off x="365760" y="402336"/>
+            <a:ext cx="11430000" cy="640080"/>
           </a:xfrm>
           <a:prstGeom prst="rect">
             <a:avLst/>
@@ -3543,167 +4000,28 @@
           </a:bodyPr>
           <a:lstStyle/>
           <a:p>
-            <a:pPr>
-              <a:spcAft>
-                <a:spcPts val="400"/>
-              </a:spcAft>
-            </a:pPr>
-            <a:r>
-              <a:rPr sz="1500">
-                <a:solidFill>
-                  <a:srgbClr val="333333"/>
-                </a:solidFill>
-              </a:rPr>
-              <a:t>▸  Suno, Udio, MusicGen saniyeler içinde insan kaydından ayırt edilemez müzik üretiyor.</a:t>
-            </a:r>
-          </a:p>
-          <a:p>
-            <a:pPr>
-              <a:spcAft>
-                <a:spcPts val="400"/>
-              </a:spcAft>
-            </a:pPr>
-            <a:r>
-              <a:rPr sz="1500">
-                <a:solidFill>
-                  <a:srgbClr val="333333"/>
-                </a:solidFill>
-              </a:rPr>
-              <a:t>▸  Telif hakkı ihlalleri, sahte hit manipülasyonu, dezenformasyon riski artıyor.</a:t>
-            </a:r>
-          </a:p>
-          <a:p>
-            <a:pPr>
-              <a:spcAft>
-                <a:spcPts val="400"/>
-              </a:spcAft>
-            </a:pPr>
-            <a:r>
-              <a:rPr sz="1500">
-                <a:solidFill>
-                  <a:srgbClr val="333333"/>
-                </a:solidFill>
-              </a:rPr>
-              <a:t>▸  Mevcut dedektörler konuşma odaklı — müzik için yetersiz kalıyor.</a:t>
-            </a:r>
-          </a:p>
-          <a:p>
-            <a:pPr>
-              <a:spcAft>
-                <a:spcPts val="400"/>
-              </a:spcAft>
-            </a:pPr>
-            <a:r>
-              <a:rPr sz="1500">
-                <a:solidFill>
-                  <a:srgbClr val="333333"/>
-                </a:solidFill>
-              </a:rPr>
-              <a:t/>
-            </a:r>
-          </a:p>
-          <a:p>
-            <a:pPr>
-              <a:spcAft>
-                <a:spcPts val="400"/>
-              </a:spcAft>
-            </a:pPr>
-            <a:r>
-              <a:rPr sz="1500">
-                <a:solidFill>
-                  <a:srgbClr val="333333"/>
-                </a:solidFill>
-              </a:rPr>
-              <a:t>Tespit açığı:</a:t>
-            </a:r>
-          </a:p>
-          <a:p>
-            <a:pPr>
-              <a:spcAft>
-                <a:spcPts val="400"/>
-              </a:spcAft>
-            </a:pPr>
-            <a:r>
-              <a:rPr sz="1500">
-                <a:solidFill>
-                  <a:srgbClr val="333333"/>
-                </a:solidFill>
-              </a:rPr>
-              <a:t>  • Müzik-spesifik heterojen öznitelik setleri yetersiz.</a:t>
-            </a:r>
-          </a:p>
-          <a:p>
-            <a:pPr>
-              <a:spcAft>
-                <a:spcPts val="400"/>
-              </a:spcAft>
-            </a:pPr>
-            <a:r>
-              <a:rPr sz="1500">
-                <a:solidFill>
-                  <a:srgbClr val="333333"/>
-                </a:solidFill>
-              </a:rPr>
-              <a:t>  • Topluluk (ensemble) yaklaşımı müzik tespitine yeterince uygulanmamış.</a:t>
-            </a:r>
-          </a:p>
-          <a:p>
-            <a:pPr>
-              <a:spcAft>
-                <a:spcPts val="400"/>
-              </a:spcAft>
-            </a:pPr>
-            <a:r>
-              <a:rPr sz="1500">
-                <a:solidFill>
-                  <a:srgbClr val="333333"/>
-                </a:solidFill>
-              </a:rPr>
-              <a:t>  • Açıklanabilir (SHAP tabanlı) sistem literatürde eksik.</a:t>
-            </a:r>
-          </a:p>
-          <a:p>
-            <a:pPr>
-              <a:spcAft>
-                <a:spcPts val="400"/>
-              </a:spcAft>
-            </a:pPr>
-            <a:r>
-              <a:rPr sz="1500">
-                <a:solidFill>
-                  <a:srgbClr val="333333"/>
-                </a:solidFill>
-              </a:rPr>
-              <a:t/>
-            </a:r>
-          </a:p>
-          <a:p>
-            <a:pPr>
-              <a:spcAft>
-                <a:spcPts val="400"/>
-              </a:spcAft>
-            </a:pPr>
-            <a:r>
-              <a:rPr sz="1500">
-                <a:solidFill>
-                  <a:srgbClr val="333333"/>
-                </a:solidFill>
-              </a:rPr>
-              <a:t>AURIS bu üç boşluğu doldurmayı hedeflemektedir.</a:t>
-            </a:r>
-          </a:p>
-        </p:txBody>
-      </p:sp>
-      <p:sp>
-        <p:nvSpPr>
-          <p:cNvPr id="5" name="TextBox 4"/>
+            <a:pPr algn="l"/>
+            <a:r>
+              <a:rPr sz="2400" b="1" i="0">
+                <a:solidFill>
+                  <a:srgbClr val="FFFFFF"/>
+                </a:solidFill>
+              </a:rPr>
+              <a:t>Problem Tanımı ve Motivasyon</a:t>
+            </a:r>
+          </a:p>
+        </p:txBody>
+      </p:sp>
+      <p:sp>
+        <p:nvSpPr>
+          <p:cNvPr id="6" name="TextBox 5"/>
           <p:cNvSpPr txBox="1"/>
           <p:nvPr/>
         </p:nvSpPr>
         <p:spPr>
           <a:xfrm>
-            <a:off x="0" y="6510528"/>
-            <a:ext cx="12188952" cy="301752"/>
+            <a:off x="365760" y="987552"/>
+            <a:ext cx="11430000" cy="365760"/>
           </a:xfrm>
           <a:prstGeom prst="rect">
             <a:avLst/>
@@ -3716,14 +4034,552 @@
           </a:bodyPr>
           <a:lstStyle/>
           <a:p>
+            <a:pPr algn="l"/>
+            <a:r>
+              <a:rPr sz="1250" b="0" i="0">
+                <a:solidFill>
+                  <a:srgbClr val="AEC6D6"/>
+                </a:solidFill>
+              </a:rPr>
+              <a:t>Üretken yapay zekânın müzik alanında yarattığı tespit ihtiyacı</a:t>
+            </a:r>
+          </a:p>
+        </p:txBody>
+      </p:sp>
+      <p:sp>
+        <p:nvSpPr>
+          <p:cNvPr id="7" name="Rectangle 6"/>
+          <p:cNvSpPr/>
+          <p:nvPr/>
+        </p:nvSpPr>
+        <p:spPr>
+          <a:xfrm>
+            <a:off x="365760" y="1600200"/>
+            <a:ext cx="5623560" cy="2103120"/>
+          </a:xfrm>
+          <a:prstGeom prst="rect">
+            <a:avLst/>
+          </a:prstGeom>
+          <a:solidFill>
+            <a:srgbClr val="FFF3E0"/>
+          </a:solidFill>
+          <a:ln>
+            <a:noFill/>
+          </a:ln>
+        </p:spPr>
+        <p:style>
+          <a:lnRef idx="1">
+            <a:schemeClr val="accent1"/>
+          </a:lnRef>
+          <a:fillRef idx="3">
+            <a:schemeClr val="accent1"/>
+          </a:fillRef>
+          <a:effectRef idx="2">
+            <a:schemeClr val="accent1"/>
+          </a:effectRef>
+          <a:fontRef idx="minor">
+            <a:schemeClr val="lt1"/>
+          </a:fontRef>
+        </p:style>
+        <p:txBody>
+          <a:bodyPr rtlCol="0" anchor="ctr"/>
+          <a:lstStyle/>
+          <a:p>
             <a:pPr algn="ctr"/>
-            <a:r>
-              <a:rPr sz="900" b="0">
-                <a:solidFill>
-                  <a:srgbClr val="8899AA"/>
-                </a:solidFill>
-              </a:rPr>
-              <a:t>Hasan Arthur Altuntaş  |  BM498  |  Düzce Üniversitesi  |  2025-2026</a:t>
+          </a:p>
+        </p:txBody>
+      </p:sp>
+      <p:sp>
+        <p:nvSpPr>
+          <p:cNvPr id="8" name="Rectangle 7"/>
+          <p:cNvSpPr/>
+          <p:nvPr/>
+        </p:nvSpPr>
+        <p:spPr>
+          <a:xfrm>
+            <a:off x="365760" y="1600200"/>
+            <a:ext cx="82296" cy="2103120"/>
+          </a:xfrm>
+          <a:prstGeom prst="rect">
+            <a:avLst/>
+          </a:prstGeom>
+          <a:solidFill>
+            <a:srgbClr val="E0A800"/>
+          </a:solidFill>
+          <a:ln>
+            <a:noFill/>
+          </a:ln>
+        </p:spPr>
+        <p:style>
+          <a:lnRef idx="1">
+            <a:schemeClr val="accent1"/>
+          </a:lnRef>
+          <a:fillRef idx="3">
+            <a:schemeClr val="accent1"/>
+          </a:fillRef>
+          <a:effectRef idx="2">
+            <a:schemeClr val="accent1"/>
+          </a:effectRef>
+          <a:fontRef idx="minor">
+            <a:schemeClr val="lt1"/>
+          </a:fontRef>
+        </p:style>
+        <p:txBody>
+          <a:bodyPr rtlCol="0" anchor="ctr"/>
+          <a:lstStyle/>
+          <a:p>
+            <a:pPr algn="ctr"/>
+          </a:p>
+        </p:txBody>
+      </p:sp>
+      <p:sp>
+        <p:nvSpPr>
+          <p:cNvPr id="9" name="TextBox 8"/>
+          <p:cNvSpPr txBox="1"/>
+          <p:nvPr/>
+        </p:nvSpPr>
+        <p:spPr>
+          <a:xfrm>
+            <a:off x="566928" y="1709928"/>
+            <a:ext cx="5303520" cy="365760"/>
+          </a:xfrm>
+          <a:prstGeom prst="rect">
+            <a:avLst/>
+          </a:prstGeom>
+          <a:noFill/>
+        </p:spPr>
+        <p:txBody>
+          <a:bodyPr wrap="square">
+            <a:spAutoFit/>
+          </a:bodyPr>
+          <a:lstStyle/>
+          <a:p>
+            <a:pPr algn="l"/>
+            <a:r>
+              <a:rPr sz="1300" b="1" i="0">
+                <a:solidFill>
+                  <a:srgbClr val="0D2B55"/>
+                </a:solidFill>
+              </a:rPr>
+              <a:t>Neden bir sorun?</a:t>
+            </a:r>
+          </a:p>
+        </p:txBody>
+      </p:sp>
+      <p:sp>
+        <p:nvSpPr>
+          <p:cNvPr id="10" name="TextBox 9"/>
+          <p:cNvSpPr txBox="1"/>
+          <p:nvPr/>
+        </p:nvSpPr>
+        <p:spPr>
+          <a:xfrm>
+            <a:off x="566928" y="2103120"/>
+            <a:ext cx="5303520" cy="1508760"/>
+          </a:xfrm>
+          <a:prstGeom prst="rect">
+            <a:avLst/>
+          </a:prstGeom>
+          <a:noFill/>
+        </p:spPr>
+        <p:txBody>
+          <a:bodyPr wrap="square">
+            <a:spAutoFit/>
+          </a:bodyPr>
+          <a:lstStyle/>
+          <a:p>
+            <a:pPr algn="l"/>
+            <a:r>
+              <a:rPr sz="1200" b="0" i="0">
+                <a:solidFill>
+                  <a:srgbClr val="2A2A2A"/>
+                </a:solidFill>
+              </a:rPr>
+              <a:t>Metinden müziğe üretim sistemleri son üç yılda araştırma laboratuvarlarından tüketici uygulamalarına taştı. Kullanıcı tek bir metin istemiyle dakikalar içinde tam uzunlukta, deneyimsiz bir dinleyicinin insan bestesinden ayırt edemeyeceği parçalar üretebiliyor.</a:t>
+            </a:r>
+          </a:p>
+        </p:txBody>
+      </p:sp>
+      <p:sp>
+        <p:nvSpPr>
+          <p:cNvPr id="11" name="Rectangle 10"/>
+          <p:cNvSpPr/>
+          <p:nvPr/>
+        </p:nvSpPr>
+        <p:spPr>
+          <a:xfrm>
+            <a:off x="365760" y="3840480"/>
+            <a:ext cx="5623560" cy="2286000"/>
+          </a:xfrm>
+          <a:prstGeom prst="rect">
+            <a:avLst/>
+          </a:prstGeom>
+          <a:solidFill>
+            <a:srgbClr val="FDE8E8"/>
+          </a:solidFill>
+          <a:ln>
+            <a:noFill/>
+          </a:ln>
+        </p:spPr>
+        <p:style>
+          <a:lnRef idx="1">
+            <a:schemeClr val="accent1"/>
+          </a:lnRef>
+          <a:fillRef idx="3">
+            <a:schemeClr val="accent1"/>
+          </a:fillRef>
+          <a:effectRef idx="2">
+            <a:schemeClr val="accent1"/>
+          </a:effectRef>
+          <a:fontRef idx="minor">
+            <a:schemeClr val="lt1"/>
+          </a:fontRef>
+        </p:style>
+        <p:txBody>
+          <a:bodyPr rtlCol="0" anchor="ctr"/>
+          <a:lstStyle/>
+          <a:p>
+            <a:pPr algn="ctr"/>
+          </a:p>
+        </p:txBody>
+      </p:sp>
+      <p:sp>
+        <p:nvSpPr>
+          <p:cNvPr id="12" name="Rectangle 11"/>
+          <p:cNvSpPr/>
+          <p:nvPr/>
+        </p:nvSpPr>
+        <p:spPr>
+          <a:xfrm>
+            <a:off x="365760" y="3840480"/>
+            <a:ext cx="82296" cy="2286000"/>
+          </a:xfrm>
+          <a:prstGeom prst="rect">
+            <a:avLst/>
+          </a:prstGeom>
+          <a:solidFill>
+            <a:srgbClr val="B52A2A"/>
+          </a:solidFill>
+          <a:ln>
+            <a:noFill/>
+          </a:ln>
+        </p:spPr>
+        <p:style>
+          <a:lnRef idx="1">
+            <a:schemeClr val="accent1"/>
+          </a:lnRef>
+          <a:fillRef idx="3">
+            <a:schemeClr val="accent1"/>
+          </a:fillRef>
+          <a:effectRef idx="2">
+            <a:schemeClr val="accent1"/>
+          </a:effectRef>
+          <a:fontRef idx="minor">
+            <a:schemeClr val="lt1"/>
+          </a:fontRef>
+        </p:style>
+        <p:txBody>
+          <a:bodyPr rtlCol="0" anchor="ctr"/>
+          <a:lstStyle/>
+          <a:p>
+            <a:pPr algn="ctr"/>
+          </a:p>
+        </p:txBody>
+      </p:sp>
+      <p:sp>
+        <p:nvSpPr>
+          <p:cNvPr id="13" name="TextBox 12"/>
+          <p:cNvSpPr txBox="1"/>
+          <p:nvPr/>
+        </p:nvSpPr>
+        <p:spPr>
+          <a:xfrm>
+            <a:off x="566928" y="3950208"/>
+            <a:ext cx="5303520" cy="365760"/>
+          </a:xfrm>
+          <a:prstGeom prst="rect">
+            <a:avLst/>
+          </a:prstGeom>
+          <a:noFill/>
+        </p:spPr>
+        <p:txBody>
+          <a:bodyPr wrap="square">
+            <a:spAutoFit/>
+          </a:bodyPr>
+          <a:lstStyle/>
+          <a:p>
+            <a:pPr algn="l"/>
+            <a:r>
+              <a:rPr sz="1300" b="1" i="0">
+                <a:solidFill>
+                  <a:srgbClr val="0D2B55"/>
+                </a:solidFill>
+              </a:rPr>
+              <a:t>Doğurduğu riskler</a:t>
+            </a:r>
+          </a:p>
+        </p:txBody>
+      </p:sp>
+      <p:sp>
+        <p:nvSpPr>
+          <p:cNvPr id="14" name="TextBox 13"/>
+          <p:cNvSpPr txBox="1"/>
+          <p:nvPr/>
+        </p:nvSpPr>
+        <p:spPr>
+          <a:xfrm>
+            <a:off x="566928" y="4343400"/>
+            <a:ext cx="5303520" cy="1691640"/>
+          </a:xfrm>
+          <a:prstGeom prst="rect">
+            <a:avLst/>
+          </a:prstGeom>
+          <a:noFill/>
+        </p:spPr>
+        <p:txBody>
+          <a:bodyPr wrap="square">
+            <a:spAutoFit/>
+          </a:bodyPr>
+          <a:lstStyle/>
+          <a:p>
+            <a:pPr algn="l"/>
+            <a:r>
+              <a:rPr sz="1200" b="0" i="0">
+                <a:solidFill>
+                  <a:srgbClr val="2A2A2A"/>
+                </a:solidFill>
+              </a:rPr>
+              <a:t>•  Telif hakkı ihlalleri ve içerik sahipliği belirsizliği
+•  Akış platformlarında sahte dinlenme / gelir manipülasyonu
+•  Dezenformasyon ve kimlik taklidi
+•  Yaratıcı endüstride ekonomik değer kaybı</a:t>
+            </a:r>
+          </a:p>
+        </p:txBody>
+      </p:sp>
+      <p:sp>
+        <p:nvSpPr>
+          <p:cNvPr id="15" name="Rectangle 14"/>
+          <p:cNvSpPr/>
+          <p:nvPr/>
+        </p:nvSpPr>
+        <p:spPr>
+          <a:xfrm>
+            <a:off x="6172200" y="1600200"/>
+            <a:ext cx="5623560" cy="4526280"/>
+          </a:xfrm>
+          <a:prstGeom prst="rect">
+            <a:avLst/>
+          </a:prstGeom>
+          <a:solidFill>
+            <a:srgbClr val="E0F0F2"/>
+          </a:solidFill>
+          <a:ln>
+            <a:noFill/>
+          </a:ln>
+        </p:spPr>
+        <p:style>
+          <a:lnRef idx="1">
+            <a:schemeClr val="accent1"/>
+          </a:lnRef>
+          <a:fillRef idx="3">
+            <a:schemeClr val="accent1"/>
+          </a:fillRef>
+          <a:effectRef idx="2">
+            <a:schemeClr val="accent1"/>
+          </a:effectRef>
+          <a:fontRef idx="minor">
+            <a:schemeClr val="lt1"/>
+          </a:fontRef>
+        </p:style>
+        <p:txBody>
+          <a:bodyPr rtlCol="0" anchor="ctr"/>
+          <a:lstStyle/>
+          <a:p>
+            <a:pPr algn="ctr"/>
+          </a:p>
+        </p:txBody>
+      </p:sp>
+      <p:sp>
+        <p:nvSpPr>
+          <p:cNvPr id="16" name="Rectangle 15"/>
+          <p:cNvSpPr/>
+          <p:nvPr/>
+        </p:nvSpPr>
+        <p:spPr>
+          <a:xfrm>
+            <a:off x="6172200" y="1600200"/>
+            <a:ext cx="82296" cy="4526280"/>
+          </a:xfrm>
+          <a:prstGeom prst="rect">
+            <a:avLst/>
+          </a:prstGeom>
+          <a:solidFill>
+            <a:srgbClr val="007A87"/>
+          </a:solidFill>
+          <a:ln>
+            <a:noFill/>
+          </a:ln>
+        </p:spPr>
+        <p:style>
+          <a:lnRef idx="1">
+            <a:schemeClr val="accent1"/>
+          </a:lnRef>
+          <a:fillRef idx="3">
+            <a:schemeClr val="accent1"/>
+          </a:fillRef>
+          <a:effectRef idx="2">
+            <a:schemeClr val="accent1"/>
+          </a:effectRef>
+          <a:fontRef idx="minor">
+            <a:schemeClr val="lt1"/>
+          </a:fontRef>
+        </p:style>
+        <p:txBody>
+          <a:bodyPr rtlCol="0" anchor="ctr"/>
+          <a:lstStyle/>
+          <a:p>
+            <a:pPr algn="ctr"/>
+          </a:p>
+        </p:txBody>
+      </p:sp>
+      <p:sp>
+        <p:nvSpPr>
+          <p:cNvPr id="17" name="TextBox 16"/>
+          <p:cNvSpPr txBox="1"/>
+          <p:nvPr/>
+        </p:nvSpPr>
+        <p:spPr>
+          <a:xfrm>
+            <a:off x="6373368" y="1709928"/>
+            <a:ext cx="5303520" cy="365760"/>
+          </a:xfrm>
+          <a:prstGeom prst="rect">
+            <a:avLst/>
+          </a:prstGeom>
+          <a:noFill/>
+        </p:spPr>
+        <p:txBody>
+          <a:bodyPr wrap="square">
+            <a:spAutoFit/>
+          </a:bodyPr>
+          <a:lstStyle/>
+          <a:p>
+            <a:pPr algn="l"/>
+            <a:r>
+              <a:rPr sz="1300" b="1" i="0">
+                <a:solidFill>
+                  <a:srgbClr val="0D2B55"/>
+                </a:solidFill>
+              </a:rPr>
+              <a:t>Mevcut yöntemlerin yetersizliği</a:t>
+            </a:r>
+          </a:p>
+        </p:txBody>
+      </p:sp>
+      <p:sp>
+        <p:nvSpPr>
+          <p:cNvPr id="18" name="TextBox 17"/>
+          <p:cNvSpPr txBox="1"/>
+          <p:nvPr/>
+        </p:nvSpPr>
+        <p:spPr>
+          <a:xfrm>
+            <a:off x="6373368" y="2103120"/>
+            <a:ext cx="5303520" cy="3931920"/>
+          </a:xfrm>
+          <a:prstGeom prst="rect">
+            <a:avLst/>
+          </a:prstGeom>
+          <a:noFill/>
+        </p:spPr>
+        <p:txBody>
+          <a:bodyPr wrap="square">
+            <a:spAutoFit/>
+          </a:bodyPr>
+          <a:lstStyle/>
+          <a:p>
+            <a:pPr algn="l"/>
+            <a:r>
+              <a:rPr sz="1200" b="0" i="0">
+                <a:solidFill>
+                  <a:srgbClr val="2A2A2A"/>
+                </a:solidFill>
+              </a:rPr>
+              <a:t>Konuşma için ses derin sahte tespiti (ADD 2022, WaveFake) olgun bir alan; ancak müzik tespiti henüz emekleme aşamasında.
+Tespit açıkları:
+•  Tek bir akustik temsile (yalnızca MFCC veya yalnızca spektrogram) bağlı kalan yaklaşımlar genelleme yapamıyor.
+•  Topluluk (ensemble) öğrenmesi müzik tespitine yeterince uygulanmamış.
+•  Kararın hangi akustik özellikten kaynaklandığını açıklayan (SHAP tabanlı) bir sistem yok.
+AURIS bu üç boşluğu birlikte ele alıyor.</a:t>
+            </a:r>
+          </a:p>
+        </p:txBody>
+      </p:sp>
+      <p:sp>
+        <p:nvSpPr>
+          <p:cNvPr id="19" name="TextBox 18"/>
+          <p:cNvSpPr txBox="1"/>
+          <p:nvPr/>
+        </p:nvSpPr>
+        <p:spPr>
+          <a:xfrm>
+            <a:off x="365760" y="6510528"/>
+            <a:ext cx="8229600" cy="301752"/>
+          </a:xfrm>
+          <a:prstGeom prst="rect">
+            <a:avLst/>
+          </a:prstGeom>
+          <a:noFill/>
+        </p:spPr>
+        <p:txBody>
+          <a:bodyPr wrap="square">
+            <a:spAutoFit/>
+          </a:bodyPr>
+          <a:lstStyle/>
+          <a:p>
+            <a:pPr algn="l"/>
+            <a:r>
+              <a:rPr sz="900" b="0" i="0">
+                <a:solidFill>
+                  <a:srgbClr val="66707A"/>
+                </a:solidFill>
+              </a:rPr>
+              <a:t>AURIS  ·  Hasan Arthur Altuntaş  ·  BM498 Mezuniyet Tezi</a:t>
+            </a:r>
+          </a:p>
+        </p:txBody>
+      </p:sp>
+      <p:sp>
+        <p:nvSpPr>
+          <p:cNvPr id="20" name="TextBox 19"/>
+          <p:cNvSpPr txBox="1"/>
+          <p:nvPr/>
+        </p:nvSpPr>
+        <p:spPr>
+          <a:xfrm>
+            <a:off x="8595360" y="6510528"/>
+            <a:ext cx="3200400" cy="301752"/>
+          </a:xfrm>
+          <a:prstGeom prst="rect">
+            <a:avLst/>
+          </a:prstGeom>
+          <a:noFill/>
+        </p:spPr>
+        <p:txBody>
+          <a:bodyPr wrap="square">
+            <a:spAutoFit/>
+          </a:bodyPr>
+          <a:lstStyle/>
+          <a:p>
+            <a:pPr algn="r"/>
+            <a:r>
+              <a:rPr sz="900" b="0" i="0">
+                <a:solidFill>
+                  <a:srgbClr val="66707A"/>
+                </a:solidFill>
+              </a:rPr>
+              <a:t>Düzce Üniversitesi · 2025-2026</a:t>
             </a:r>
           </a:p>
         </p:txBody>
@@ -3763,7 +4619,7 @@
         <p:spPr>
           <a:xfrm>
             <a:off x="0" y="0"/>
-            <a:ext cx="12188952" cy="1417320"/>
+            <a:ext cx="12188952" cy="1371600"/>
           </a:xfrm>
           <a:prstGeom prst="rect">
             <a:avLst/>
@@ -3799,14 +4655,57 @@
       </p:sp>
       <p:sp>
         <p:nvSpPr>
-          <p:cNvPr id="3" name="TextBox 2"/>
+          <p:cNvPr id="3" name="Rectangle 2"/>
+          <p:cNvSpPr/>
+          <p:nvPr/>
+        </p:nvSpPr>
+        <p:spPr>
+          <a:xfrm>
+            <a:off x="0" y="1371600"/>
+            <a:ext cx="12188952" cy="54864"/>
+          </a:xfrm>
+          <a:prstGeom prst="rect">
+            <a:avLst/>
+          </a:prstGeom>
+          <a:solidFill>
+            <a:srgbClr val="E0A800"/>
+          </a:solidFill>
+          <a:ln>
+            <a:noFill/>
+          </a:ln>
+        </p:spPr>
+        <p:style>
+          <a:lnRef idx="1">
+            <a:schemeClr val="accent1"/>
+          </a:lnRef>
+          <a:fillRef idx="3">
+            <a:schemeClr val="accent1"/>
+          </a:fillRef>
+          <a:effectRef idx="2">
+            <a:schemeClr val="accent1"/>
+          </a:effectRef>
+          <a:fontRef idx="minor">
+            <a:schemeClr val="lt1"/>
+          </a:fontRef>
+        </p:style>
+        <p:txBody>
+          <a:bodyPr rtlCol="0" anchor="ctr"/>
+          <a:lstStyle/>
+          <a:p>
+            <a:pPr algn="ctr"/>
+          </a:p>
+        </p:txBody>
+      </p:sp>
+      <p:sp>
+        <p:nvSpPr>
+          <p:cNvPr id="4" name="TextBox 3"/>
           <p:cNvSpPr txBox="1"/>
           <p:nvPr/>
         </p:nvSpPr>
         <p:spPr>
           <a:xfrm>
-            <a:off x="320040" y="91440"/>
-            <a:ext cx="11521440" cy="822960"/>
+            <a:off x="365760" y="109728"/>
+            <a:ext cx="11430000" cy="320040"/>
           </a:xfrm>
           <a:prstGeom prst="rect">
             <a:avLst/>
@@ -3821,26 +4720,26 @@
           <a:p>
             <a:pPr algn="l"/>
             <a:r>
-              <a:rPr sz="2500" b="1">
-                <a:solidFill>
-                  <a:srgbClr val="FFFFFF"/>
-                </a:solidFill>
-              </a:rPr>
-              <a:t>Planlanan Yöntem ve Zaman Planı</a:t>
-            </a:r>
-          </a:p>
-        </p:txBody>
-      </p:sp>
-      <p:sp>
-        <p:nvSpPr>
-          <p:cNvPr id="4" name="TextBox 3"/>
+              <a:rPr sz="1100" b="1" i="0">
+                <a:solidFill>
+                  <a:srgbClr val="E0A800"/>
+                </a:solidFill>
+              </a:rPr>
+              <a:t>BÖLÜM 1 · GIRIŞ</a:t>
+            </a:r>
+          </a:p>
+        </p:txBody>
+      </p:sp>
+      <p:sp>
+        <p:nvSpPr>
+          <p:cNvPr id="5" name="TextBox 4"/>
           <p:cNvSpPr txBox="1"/>
           <p:nvPr/>
         </p:nvSpPr>
         <p:spPr>
           <a:xfrm>
-            <a:off x="457200" y="1554480"/>
-            <a:ext cx="5486400" cy="4754880"/>
+            <a:off x="365760" y="402336"/>
+            <a:ext cx="11430000" cy="640080"/>
           </a:xfrm>
           <a:prstGeom prst="rect">
             <a:avLst/>
@@ -3853,167 +4752,28 @@
           </a:bodyPr>
           <a:lstStyle/>
           <a:p>
-            <a:pPr>
-              <a:spcAft>
-                <a:spcPts val="400"/>
-              </a:spcAft>
-            </a:pPr>
-            <a:r>
-              <a:rPr sz="1400">
-                <a:solidFill>
-                  <a:srgbClr val="333333"/>
-                </a:solidFill>
-              </a:rPr>
-              <a:t>Veri:</a:t>
-            </a:r>
-          </a:p>
-          <a:p>
-            <a:pPr>
-              <a:spcAft>
-                <a:spcPts val="400"/>
-              </a:spcAft>
-            </a:pPr>
-            <a:r>
-              <a:rPr sz="1400">
-                <a:solidFill>
-                  <a:srgbClr val="333333"/>
-                </a:solidFill>
-              </a:rPr>
-              <a:t>  5.195 örnek — çoklu insan + YZ kaynağı</a:t>
-            </a:r>
-          </a:p>
-          <a:p>
-            <a:pPr>
-              <a:spcAft>
-                <a:spcPts val="400"/>
-              </a:spcAft>
-            </a:pPr>
-            <a:r>
-              <a:rPr sz="1400">
-                <a:solidFill>
-                  <a:srgbClr val="333333"/>
-                </a:solidFill>
-              </a:rPr>
-              <a:t>Öznitelik:</a:t>
-            </a:r>
-          </a:p>
-          <a:p>
-            <a:pPr>
-              <a:spcAft>
-                <a:spcPts val="400"/>
-              </a:spcAft>
-            </a:pPr>
-            <a:r>
-              <a:rPr sz="1400">
-                <a:solidFill>
-                  <a:srgbClr val="333333"/>
-                </a:solidFill>
-              </a:rPr>
-              <a:t>  47 boyutlu akustik vektör</a:t>
-            </a:r>
-          </a:p>
-          <a:p>
-            <a:pPr>
-              <a:spcAft>
-                <a:spcPts val="400"/>
-              </a:spcAft>
-            </a:pPr>
-            <a:r>
-              <a:rPr sz="1400">
-                <a:solidFill>
-                  <a:srgbClr val="333333"/>
-                </a:solidFill>
-              </a:rPr>
-              <a:t>  (spektral, zamansal, ritmik, harmonik, vokal)</a:t>
-            </a:r>
-          </a:p>
-          <a:p>
-            <a:pPr>
-              <a:spcAft>
-                <a:spcPts val="400"/>
-              </a:spcAft>
-            </a:pPr>
-            <a:r>
-              <a:rPr sz="1400">
-                <a:solidFill>
-                  <a:srgbClr val="333333"/>
-                </a:solidFill>
-              </a:rPr>
-              <a:t>Model:</a:t>
-            </a:r>
-          </a:p>
-          <a:p>
-            <a:pPr>
-              <a:spcAft>
-                <a:spcPts val="400"/>
-              </a:spcAft>
-            </a:pPr>
-            <a:r>
-              <a:rPr sz="1400">
-                <a:solidFill>
-                  <a:srgbClr val="333333"/>
-                </a:solidFill>
-              </a:rPr>
-              <a:t>  11 model topluluğu (7 ML + 4 DL)</a:t>
-            </a:r>
-          </a:p>
-          <a:p>
-            <a:pPr>
-              <a:spcAft>
-                <a:spcPts val="400"/>
-              </a:spcAft>
-            </a:pPr>
-            <a:r>
-              <a:rPr sz="1400">
-                <a:solidFill>
-                  <a:srgbClr val="333333"/>
-                </a:solidFill>
-              </a:rPr>
-              <a:t>  LightGBM lider model</a:t>
-            </a:r>
-          </a:p>
-          <a:p>
-            <a:pPr>
-              <a:spcAft>
-                <a:spcPts val="400"/>
-              </a:spcAft>
-            </a:pPr>
-            <a:r>
-              <a:rPr sz="1400">
-                <a:solidFill>
-                  <a:srgbClr val="333333"/>
-                </a:solidFill>
-              </a:rPr>
-              <a:t>Değerlendirme:</a:t>
-            </a:r>
-          </a:p>
-          <a:p>
-            <a:pPr>
-              <a:spcAft>
-                <a:spcPts val="400"/>
-              </a:spcAft>
-            </a:pPr>
-            <a:r>
-              <a:rPr sz="1400">
-                <a:solidFill>
-                  <a:srgbClr val="333333"/>
-                </a:solidFill>
-              </a:rPr>
-              <a:t>  5-katlı çapraz doğrulama, SHAP</a:t>
-            </a:r>
-          </a:p>
-        </p:txBody>
-      </p:sp>
-      <p:sp>
-        <p:nvSpPr>
-          <p:cNvPr id="5" name="TextBox 4"/>
+            <a:pPr algn="l"/>
+            <a:r>
+              <a:rPr sz="2400" b="1" i="0">
+                <a:solidFill>
+                  <a:srgbClr val="FFFFFF"/>
+                </a:solidFill>
+              </a:rPr>
+              <a:t>Çalışmanın Amacı ve Literatüre Katkısı</a:t>
+            </a:r>
+          </a:p>
+        </p:txBody>
+      </p:sp>
+      <p:sp>
+        <p:nvSpPr>
+          <p:cNvPr id="6" name="TextBox 5"/>
           <p:cNvSpPr txBox="1"/>
           <p:nvPr/>
         </p:nvSpPr>
         <p:spPr>
           <a:xfrm>
-            <a:off x="6217920" y="1554480"/>
-            <a:ext cx="5577840" cy="4754880"/>
+            <a:off x="365760" y="1554480"/>
+            <a:ext cx="5669280" cy="411480"/>
           </a:xfrm>
           <a:prstGeom prst="rect">
             <a:avLst/>
@@ -4026,167 +4786,28 @@
           </a:bodyPr>
           <a:lstStyle/>
           <a:p>
-            <a:pPr>
-              <a:spcAft>
-                <a:spcPts val="400"/>
-              </a:spcAft>
-            </a:pPr>
-            <a:r>
-              <a:rPr sz="1400">
-                <a:solidFill>
-                  <a:srgbClr val="333333"/>
-                </a:solidFill>
-              </a:rPr>
-              <a:t>Hafta 1-2 :  Veri toplama ve ön işleme</a:t>
-            </a:r>
-          </a:p>
-          <a:p>
-            <a:pPr>
-              <a:spcAft>
-                <a:spcPts val="400"/>
-              </a:spcAft>
-            </a:pPr>
-            <a:r>
-              <a:rPr sz="1400">
-                <a:solidFill>
-                  <a:srgbClr val="333333"/>
-                </a:solidFill>
-              </a:rPr>
-              <a:t>Hafta 3-4 :  Öznitelik mühendisliği</a:t>
-            </a:r>
-          </a:p>
-          <a:p>
-            <a:pPr>
-              <a:spcAft>
-                <a:spcPts val="400"/>
-              </a:spcAft>
-            </a:pPr>
-            <a:r>
-              <a:rPr sz="1400">
-                <a:solidFill>
-                  <a:srgbClr val="333333"/>
-                </a:solidFill>
-              </a:rPr>
-              <a:t>Hafta 5-6 :  Model eğitimi ve CV</a:t>
-            </a:r>
-          </a:p>
-          <a:p>
-            <a:pPr>
-              <a:spcAft>
-                <a:spcPts val="400"/>
-              </a:spcAft>
-            </a:pPr>
-            <a:r>
-              <a:rPr sz="1400">
-                <a:solidFill>
-                  <a:srgbClr val="333333"/>
-                </a:solidFill>
-              </a:rPr>
-              <a:t>Hafta 7-8 :  Değerlendirme ve SHAP</a:t>
-            </a:r>
-          </a:p>
-          <a:p>
-            <a:pPr>
-              <a:spcAft>
-                <a:spcPts val="400"/>
-              </a:spcAft>
-            </a:pPr>
-            <a:r>
-              <a:rPr sz="1400">
-                <a:solidFill>
-                  <a:srgbClr val="333333"/>
-                </a:solidFill>
-              </a:rPr>
-              <a:t>Hafta 9-10:  Yazım ve sunum hazırlığı</a:t>
-            </a:r>
-          </a:p>
-          <a:p>
-            <a:pPr>
-              <a:spcAft>
-                <a:spcPts val="400"/>
-              </a:spcAft>
-            </a:pPr>
-            <a:r>
-              <a:rPr sz="1400">
-                <a:solidFill>
-                  <a:srgbClr val="333333"/>
-                </a:solidFill>
-              </a:rPr>
-              <a:t/>
-            </a:r>
-          </a:p>
-          <a:p>
-            <a:pPr>
-              <a:spcAft>
-                <a:spcPts val="400"/>
-              </a:spcAft>
-            </a:pPr>
-            <a:r>
-              <a:rPr sz="1400">
-                <a:solidFill>
-                  <a:srgbClr val="333333"/>
-                </a:solidFill>
-              </a:rPr>
-              <a:t>Risk analizi:</a:t>
-            </a:r>
-          </a:p>
-          <a:p>
-            <a:pPr>
-              <a:spcAft>
-                <a:spcPts val="400"/>
-              </a:spcAft>
-            </a:pPr>
-            <a:r>
-              <a:rPr sz="1400">
-                <a:solidFill>
-                  <a:srgbClr val="333333"/>
-                </a:solidFill>
-              </a:rPr>
-              <a:t>  Sınıf dengesizliği → class_weight</a:t>
-            </a:r>
-          </a:p>
-          <a:p>
-            <a:pPr>
-              <a:spcAft>
-                <a:spcPts val="400"/>
-              </a:spcAft>
-            </a:pPr>
-            <a:r>
-              <a:rPr sz="1400">
-                <a:solidFill>
-                  <a:srgbClr val="333333"/>
-                </a:solidFill>
-              </a:rPr>
-              <a:t>  DL eğitim süresi → erken durdurma</a:t>
-            </a:r>
-          </a:p>
-          <a:p>
-            <a:pPr>
-              <a:spcAft>
-                <a:spcPts val="400"/>
-              </a:spcAft>
-            </a:pPr>
-            <a:r>
-              <a:rPr sz="1400">
-                <a:solidFill>
-                  <a:srgbClr val="333333"/>
-                </a:solidFill>
-              </a:rPr>
-              <a:t>  Genelleme → ileri çalışma kapsamı</a:t>
-            </a:r>
-          </a:p>
-        </p:txBody>
-      </p:sp>
-      <p:sp>
-        <p:nvSpPr>
-          <p:cNvPr id="6" name="TextBox 5"/>
+            <a:pPr algn="l"/>
+            <a:r>
+              <a:rPr sz="1500" b="1" i="0">
+                <a:solidFill>
+                  <a:srgbClr val="0D2B55"/>
+                </a:solidFill>
+              </a:rPr>
+              <a:t>Araştırma Hedefleri</a:t>
+            </a:r>
+          </a:p>
+        </p:txBody>
+      </p:sp>
+      <p:sp>
+        <p:nvSpPr>
+          <p:cNvPr id="7" name="TextBox 6"/>
           <p:cNvSpPr txBox="1"/>
           <p:nvPr/>
         </p:nvSpPr>
         <p:spPr>
           <a:xfrm>
-            <a:off x="0" y="6510528"/>
-            <a:ext cx="12188952" cy="301752"/>
+            <a:off x="411480" y="2011680"/>
+            <a:ext cx="5577840" cy="4206240"/>
           </a:xfrm>
           <a:prstGeom prst="rect">
             <a:avLst/>
@@ -4199,14 +4820,657 @@
           </a:bodyPr>
           <a:lstStyle/>
           <a:p>
+            <a:pPr>
+              <a:spcAft>
+                <a:spcPts val="1200"/>
+              </a:spcAft>
+            </a:pPr>
+            <a:r>
+              <a:rPr sz="1350">
+                <a:solidFill>
+                  <a:srgbClr val="2A2A2A"/>
+                </a:solidFill>
+              </a:rPr>
+              <a:t>•  Müzik-spesifik, çok aileli 47 boyutlu öznitelik vektörü tasarlamak</a:t>
+            </a:r>
+          </a:p>
+          <a:p>
+            <a:pPr>
+              <a:spcAft>
+                <a:spcPts val="1200"/>
+              </a:spcAft>
+            </a:pPr>
+            <a:r>
+              <a:rPr sz="1350">
+                <a:solidFill>
+                  <a:srgbClr val="2A2A2A"/>
+                </a:solidFill>
+              </a:rPr>
+              <a:t>•  Yedi makine öğrenmesi + dört derin öğrenme modelini ortak protokolde karşılaştırmak</a:t>
+            </a:r>
+          </a:p>
+          <a:p>
+            <a:pPr>
+              <a:spcAft>
+                <a:spcPts val="1200"/>
+              </a:spcAft>
+            </a:pPr>
+            <a:r>
+              <a:rPr sz="1350">
+                <a:solidFill>
+                  <a:srgbClr val="2A2A2A"/>
+                </a:solidFill>
+              </a:rPr>
+              <a:t>•  5-katlı çapraz doğrulama ile güvenilir, varyansı düşük değerlendirme yapmak</a:t>
+            </a:r>
+          </a:p>
+          <a:p>
+            <a:pPr>
+              <a:spcAft>
+                <a:spcPts val="1200"/>
+              </a:spcAft>
+            </a:pPr>
+            <a:r>
+              <a:rPr sz="1350">
+                <a:solidFill>
+                  <a:srgbClr val="2A2A2A"/>
+                </a:solidFill>
+              </a:rPr>
+              <a:t>•  Youden J ile karar eşiğini optimize etmek</a:t>
+            </a:r>
+          </a:p>
+          <a:p>
+            <a:pPr>
+              <a:spcAft>
+                <a:spcPts val="1200"/>
+              </a:spcAft>
+            </a:pPr>
+            <a:r>
+              <a:rPr sz="1350">
+                <a:solidFill>
+                  <a:srgbClr val="2A2A2A"/>
+                </a:solidFill>
+              </a:rPr>
+              <a:t>•  TreeSHAP ile kararı açıklanabilir kılmak</a:t>
+            </a:r>
+          </a:p>
+          <a:p>
+            <a:pPr>
+              <a:spcAft>
+                <a:spcPts val="1200"/>
+              </a:spcAft>
+            </a:pPr>
+            <a:r>
+              <a:rPr sz="1350">
+                <a:solidFill>
+                  <a:srgbClr val="2A2A2A"/>
+                </a:solidFill>
+              </a:rPr>
+              <a:t>•  GUJSA formatında akademik yayın üretmek</a:t>
+            </a:r>
+          </a:p>
+        </p:txBody>
+      </p:sp>
+      <p:sp>
+        <p:nvSpPr>
+          <p:cNvPr id="8" name="TextBox 7"/>
+          <p:cNvSpPr txBox="1"/>
+          <p:nvPr/>
+        </p:nvSpPr>
+        <p:spPr>
+          <a:xfrm>
+            <a:off x="6309360" y="1554480"/>
+            <a:ext cx="5486400" cy="411480"/>
+          </a:xfrm>
+          <a:prstGeom prst="rect">
+            <a:avLst/>
+          </a:prstGeom>
+          <a:noFill/>
+        </p:spPr>
+        <p:txBody>
+          <a:bodyPr wrap="square">
+            <a:spAutoFit/>
+          </a:bodyPr>
+          <a:lstStyle/>
+          <a:p>
+            <a:pPr algn="l"/>
+            <a:r>
+              <a:rPr sz="1500" b="1" i="0">
+                <a:solidFill>
+                  <a:srgbClr val="0D2B55"/>
+                </a:solidFill>
+              </a:rPr>
+              <a:t>Literatürdeki Konumu</a:t>
+            </a:r>
+          </a:p>
+        </p:txBody>
+      </p:sp>
+      <p:sp>
+        <p:nvSpPr>
+          <p:cNvPr id="9" name="Rectangle 8"/>
+          <p:cNvSpPr/>
+          <p:nvPr/>
+        </p:nvSpPr>
+        <p:spPr>
+          <a:xfrm>
+            <a:off x="6309360" y="2057400"/>
+            <a:ext cx="5486400" cy="1508760"/>
+          </a:xfrm>
+          <a:prstGeom prst="rect">
+            <a:avLst/>
+          </a:prstGeom>
+          <a:solidFill>
+            <a:srgbClr val="E8ECF0"/>
+          </a:solidFill>
+          <a:ln>
+            <a:noFill/>
+          </a:ln>
+        </p:spPr>
+        <p:style>
+          <a:lnRef idx="1">
+            <a:schemeClr val="accent1"/>
+          </a:lnRef>
+          <a:fillRef idx="3">
+            <a:schemeClr val="accent1"/>
+          </a:fillRef>
+          <a:effectRef idx="2">
+            <a:schemeClr val="accent1"/>
+          </a:effectRef>
+          <a:fontRef idx="minor">
+            <a:schemeClr val="lt1"/>
+          </a:fontRef>
+        </p:style>
+        <p:txBody>
+          <a:bodyPr rtlCol="0" anchor="ctr"/>
+          <a:lstStyle/>
+          <a:p>
             <a:pPr algn="ctr"/>
-            <a:r>
-              <a:rPr sz="900" b="0">
-                <a:solidFill>
-                  <a:srgbClr val="8899AA"/>
-                </a:solidFill>
-              </a:rPr>
-              <a:t>Hasan Arthur Altuntaş  |  BM498  |  Düzce Üniversitesi  |  2025-2026</a:t>
+          </a:p>
+        </p:txBody>
+      </p:sp>
+      <p:sp>
+        <p:nvSpPr>
+          <p:cNvPr id="10" name="Rectangle 9"/>
+          <p:cNvSpPr/>
+          <p:nvPr/>
+        </p:nvSpPr>
+        <p:spPr>
+          <a:xfrm>
+            <a:off x="6309360" y="2057400"/>
+            <a:ext cx="82296" cy="1508760"/>
+          </a:xfrm>
+          <a:prstGeom prst="rect">
+            <a:avLst/>
+          </a:prstGeom>
+          <a:solidFill>
+            <a:srgbClr val="007A87"/>
+          </a:solidFill>
+          <a:ln>
+            <a:noFill/>
+          </a:ln>
+        </p:spPr>
+        <p:style>
+          <a:lnRef idx="1">
+            <a:schemeClr val="accent1"/>
+          </a:lnRef>
+          <a:fillRef idx="3">
+            <a:schemeClr val="accent1"/>
+          </a:fillRef>
+          <a:effectRef idx="2">
+            <a:schemeClr val="accent1"/>
+          </a:effectRef>
+          <a:fontRef idx="minor">
+            <a:schemeClr val="lt1"/>
+          </a:fontRef>
+        </p:style>
+        <p:txBody>
+          <a:bodyPr rtlCol="0" anchor="ctr"/>
+          <a:lstStyle/>
+          <a:p>
+            <a:pPr algn="ctr"/>
+          </a:p>
+        </p:txBody>
+      </p:sp>
+      <p:sp>
+        <p:nvSpPr>
+          <p:cNvPr id="11" name="TextBox 10"/>
+          <p:cNvSpPr txBox="1"/>
+          <p:nvPr/>
+        </p:nvSpPr>
+        <p:spPr>
+          <a:xfrm>
+            <a:off x="6510528" y="2167128"/>
+            <a:ext cx="5166360" cy="365760"/>
+          </a:xfrm>
+          <a:prstGeom prst="rect">
+            <a:avLst/>
+          </a:prstGeom>
+          <a:noFill/>
+        </p:spPr>
+        <p:txBody>
+          <a:bodyPr wrap="square">
+            <a:spAutoFit/>
+          </a:bodyPr>
+          <a:lstStyle/>
+          <a:p>
+            <a:pPr algn="l"/>
+            <a:r>
+              <a:rPr sz="1300" b="1" i="0">
+                <a:solidFill>
+                  <a:srgbClr val="0D2B55"/>
+                </a:solidFill>
+              </a:rPr>
+              <a:t>Özgün değer</a:t>
+            </a:r>
+          </a:p>
+        </p:txBody>
+      </p:sp>
+      <p:sp>
+        <p:nvSpPr>
+          <p:cNvPr id="12" name="TextBox 11"/>
+          <p:cNvSpPr txBox="1"/>
+          <p:nvPr/>
+        </p:nvSpPr>
+        <p:spPr>
+          <a:xfrm>
+            <a:off x="6510528" y="2560320"/>
+            <a:ext cx="5166360" cy="914399"/>
+          </a:xfrm>
+          <a:prstGeom prst="rect">
+            <a:avLst/>
+          </a:prstGeom>
+          <a:noFill/>
+        </p:spPr>
+        <p:txBody>
+          <a:bodyPr wrap="square">
+            <a:spAutoFit/>
+          </a:bodyPr>
+          <a:lstStyle/>
+          <a:p>
+            <a:pPr algn="l"/>
+            <a:r>
+              <a:rPr sz="1200" b="0" i="0">
+                <a:solidFill>
+                  <a:srgbClr val="2A2A2A"/>
+                </a:solidFill>
+              </a:rPr>
+              <a:t>AURIS, müzik deepfake tespitinde topluluk öğrenmesi ile SHAP açıklanabilirliğini birleştiren ilk çalışmalardandır.</a:t>
+            </a:r>
+          </a:p>
+        </p:txBody>
+      </p:sp>
+      <p:sp>
+        <p:nvSpPr>
+          <p:cNvPr id="13" name="Rectangle 12"/>
+          <p:cNvSpPr/>
+          <p:nvPr/>
+        </p:nvSpPr>
+        <p:spPr>
+          <a:xfrm>
+            <a:off x="6309360" y="3749039"/>
+            <a:ext cx="5486400" cy="1280160"/>
+          </a:xfrm>
+          <a:prstGeom prst="rect">
+            <a:avLst/>
+          </a:prstGeom>
+          <a:solidFill>
+            <a:srgbClr val="E8ECF0"/>
+          </a:solidFill>
+          <a:ln>
+            <a:noFill/>
+          </a:ln>
+        </p:spPr>
+        <p:style>
+          <a:lnRef idx="1">
+            <a:schemeClr val="accent1"/>
+          </a:lnRef>
+          <a:fillRef idx="3">
+            <a:schemeClr val="accent1"/>
+          </a:fillRef>
+          <a:effectRef idx="2">
+            <a:schemeClr val="accent1"/>
+          </a:effectRef>
+          <a:fontRef idx="minor">
+            <a:schemeClr val="lt1"/>
+          </a:fontRef>
+        </p:style>
+        <p:txBody>
+          <a:bodyPr rtlCol="0" anchor="ctr"/>
+          <a:lstStyle/>
+          <a:p>
+            <a:pPr algn="ctr"/>
+          </a:p>
+        </p:txBody>
+      </p:sp>
+      <p:sp>
+        <p:nvSpPr>
+          <p:cNvPr id="14" name="Rectangle 13"/>
+          <p:cNvSpPr/>
+          <p:nvPr/>
+        </p:nvSpPr>
+        <p:spPr>
+          <a:xfrm>
+            <a:off x="6309360" y="3749039"/>
+            <a:ext cx="82296" cy="1280160"/>
+          </a:xfrm>
+          <a:prstGeom prst="rect">
+            <a:avLst/>
+          </a:prstGeom>
+          <a:solidFill>
+            <a:srgbClr val="E0A800"/>
+          </a:solidFill>
+          <a:ln>
+            <a:noFill/>
+          </a:ln>
+        </p:spPr>
+        <p:style>
+          <a:lnRef idx="1">
+            <a:schemeClr val="accent1"/>
+          </a:lnRef>
+          <a:fillRef idx="3">
+            <a:schemeClr val="accent1"/>
+          </a:fillRef>
+          <a:effectRef idx="2">
+            <a:schemeClr val="accent1"/>
+          </a:effectRef>
+          <a:fontRef idx="minor">
+            <a:schemeClr val="lt1"/>
+          </a:fontRef>
+        </p:style>
+        <p:txBody>
+          <a:bodyPr rtlCol="0" anchor="ctr"/>
+          <a:lstStyle/>
+          <a:p>
+            <a:pPr algn="ctr"/>
+          </a:p>
+        </p:txBody>
+      </p:sp>
+      <p:sp>
+        <p:nvSpPr>
+          <p:cNvPr id="15" name="TextBox 14"/>
+          <p:cNvSpPr txBox="1"/>
+          <p:nvPr/>
+        </p:nvSpPr>
+        <p:spPr>
+          <a:xfrm>
+            <a:off x="6510528" y="3858768"/>
+            <a:ext cx="5166360" cy="365760"/>
+          </a:xfrm>
+          <a:prstGeom prst="rect">
+            <a:avLst/>
+          </a:prstGeom>
+          <a:noFill/>
+        </p:spPr>
+        <p:txBody>
+          <a:bodyPr wrap="square">
+            <a:spAutoFit/>
+          </a:bodyPr>
+          <a:lstStyle/>
+          <a:p>
+            <a:pPr algn="l"/>
+            <a:r>
+              <a:rPr sz="1300" b="1" i="0">
+                <a:solidFill>
+                  <a:srgbClr val="0D2B55"/>
+                </a:solidFill>
+              </a:rPr>
+              <a:t>Hafiflik avantajı</a:t>
+            </a:r>
+          </a:p>
+        </p:txBody>
+      </p:sp>
+      <p:sp>
+        <p:nvSpPr>
+          <p:cNvPr id="16" name="TextBox 15"/>
+          <p:cNvSpPr txBox="1"/>
+          <p:nvPr/>
+        </p:nvSpPr>
+        <p:spPr>
+          <a:xfrm>
+            <a:off x="6510528" y="4251959"/>
+            <a:ext cx="5166360" cy="685799"/>
+          </a:xfrm>
+          <a:prstGeom prst="rect">
+            <a:avLst/>
+          </a:prstGeom>
+          <a:noFill/>
+        </p:spPr>
+        <p:txBody>
+          <a:bodyPr wrap="square">
+            <a:spAutoFit/>
+          </a:bodyPr>
+          <a:lstStyle/>
+          <a:p>
+            <a:pPr algn="l"/>
+            <a:r>
+              <a:rPr sz="1200" b="0" i="0">
+                <a:solidFill>
+                  <a:srgbClr val="2A2A2A"/>
+                </a:solidFill>
+              </a:rPr>
+              <a:t>Derin öğrenme altyapısı gerektirmeden, elle tasarlanmış özniteliklerle rekabetçi doğruluk hedefleniyor.</a:t>
+            </a:r>
+          </a:p>
+        </p:txBody>
+      </p:sp>
+      <p:sp>
+        <p:nvSpPr>
+          <p:cNvPr id="17" name="Rectangle 16"/>
+          <p:cNvSpPr/>
+          <p:nvPr/>
+        </p:nvSpPr>
+        <p:spPr>
+          <a:xfrm>
+            <a:off x="6309360" y="5212080"/>
+            <a:ext cx="5486400" cy="960120"/>
+          </a:xfrm>
+          <a:prstGeom prst="rect">
+            <a:avLst/>
+          </a:prstGeom>
+          <a:solidFill>
+            <a:srgbClr val="E8ECF0"/>
+          </a:solidFill>
+          <a:ln>
+            <a:noFill/>
+          </a:ln>
+        </p:spPr>
+        <p:style>
+          <a:lnRef idx="1">
+            <a:schemeClr val="accent1"/>
+          </a:lnRef>
+          <a:fillRef idx="3">
+            <a:schemeClr val="accent1"/>
+          </a:fillRef>
+          <a:effectRef idx="2">
+            <a:schemeClr val="accent1"/>
+          </a:effectRef>
+          <a:fontRef idx="minor">
+            <a:schemeClr val="lt1"/>
+          </a:fontRef>
+        </p:style>
+        <p:txBody>
+          <a:bodyPr rtlCol="0" anchor="ctr"/>
+          <a:lstStyle/>
+          <a:p>
+            <a:pPr algn="ctr"/>
+          </a:p>
+        </p:txBody>
+      </p:sp>
+      <p:sp>
+        <p:nvSpPr>
+          <p:cNvPr id="18" name="Rectangle 17"/>
+          <p:cNvSpPr/>
+          <p:nvPr/>
+        </p:nvSpPr>
+        <p:spPr>
+          <a:xfrm>
+            <a:off x="6309360" y="5212080"/>
+            <a:ext cx="82296" cy="960120"/>
+          </a:xfrm>
+          <a:prstGeom prst="rect">
+            <a:avLst/>
+          </a:prstGeom>
+          <a:solidFill>
+            <a:srgbClr val="1A6B3A"/>
+          </a:solidFill>
+          <a:ln>
+            <a:noFill/>
+          </a:ln>
+        </p:spPr>
+        <p:style>
+          <a:lnRef idx="1">
+            <a:schemeClr val="accent1"/>
+          </a:lnRef>
+          <a:fillRef idx="3">
+            <a:schemeClr val="accent1"/>
+          </a:fillRef>
+          <a:effectRef idx="2">
+            <a:schemeClr val="accent1"/>
+          </a:effectRef>
+          <a:fontRef idx="minor">
+            <a:schemeClr val="lt1"/>
+          </a:fontRef>
+        </p:style>
+        <p:txBody>
+          <a:bodyPr rtlCol="0" anchor="ctr"/>
+          <a:lstStyle/>
+          <a:p>
+            <a:pPr algn="ctr"/>
+          </a:p>
+        </p:txBody>
+      </p:sp>
+      <p:sp>
+        <p:nvSpPr>
+          <p:cNvPr id="19" name="TextBox 18"/>
+          <p:cNvSpPr txBox="1"/>
+          <p:nvPr/>
+        </p:nvSpPr>
+        <p:spPr>
+          <a:xfrm>
+            <a:off x="6510528" y="5321808"/>
+            <a:ext cx="5166360" cy="365760"/>
+          </a:xfrm>
+          <a:prstGeom prst="rect">
+            <a:avLst/>
+          </a:prstGeom>
+          <a:noFill/>
+        </p:spPr>
+        <p:txBody>
+          <a:bodyPr wrap="square">
+            <a:spAutoFit/>
+          </a:bodyPr>
+          <a:lstStyle/>
+          <a:p>
+            <a:pPr algn="l"/>
+            <a:r>
+              <a:rPr sz="1300" b="1" i="0">
+                <a:solidFill>
+                  <a:srgbClr val="0D2B55"/>
+                </a:solidFill>
+              </a:rPr>
+              <a:t>Açıklanabilirlik</a:t>
+            </a:r>
+          </a:p>
+        </p:txBody>
+      </p:sp>
+      <p:sp>
+        <p:nvSpPr>
+          <p:cNvPr id="20" name="TextBox 19"/>
+          <p:cNvSpPr txBox="1"/>
+          <p:nvPr/>
+        </p:nvSpPr>
+        <p:spPr>
+          <a:xfrm>
+            <a:off x="6510528" y="5715000"/>
+            <a:ext cx="5166360" cy="365760"/>
+          </a:xfrm>
+          <a:prstGeom prst="rect">
+            <a:avLst/>
+          </a:prstGeom>
+          <a:noFill/>
+        </p:spPr>
+        <p:txBody>
+          <a:bodyPr wrap="square">
+            <a:spAutoFit/>
+          </a:bodyPr>
+          <a:lstStyle/>
+          <a:p>
+            <a:pPr algn="l"/>
+            <a:r>
+              <a:rPr sz="1200" b="0" i="0">
+                <a:solidFill>
+                  <a:srgbClr val="2A2A2A"/>
+                </a:solidFill>
+              </a:rPr>
+              <a:t>Her tahmin, hangi akustik özelliğin kararı yönlendirdiğiyle birlikte sunulur.</a:t>
+            </a:r>
+          </a:p>
+        </p:txBody>
+      </p:sp>
+      <p:sp>
+        <p:nvSpPr>
+          <p:cNvPr id="21" name="TextBox 20"/>
+          <p:cNvSpPr txBox="1"/>
+          <p:nvPr/>
+        </p:nvSpPr>
+        <p:spPr>
+          <a:xfrm>
+            <a:off x="365760" y="6510528"/>
+            <a:ext cx="8229600" cy="301752"/>
+          </a:xfrm>
+          <a:prstGeom prst="rect">
+            <a:avLst/>
+          </a:prstGeom>
+          <a:noFill/>
+        </p:spPr>
+        <p:txBody>
+          <a:bodyPr wrap="square">
+            <a:spAutoFit/>
+          </a:bodyPr>
+          <a:lstStyle/>
+          <a:p>
+            <a:pPr algn="l"/>
+            <a:r>
+              <a:rPr sz="900" b="0" i="0">
+                <a:solidFill>
+                  <a:srgbClr val="66707A"/>
+                </a:solidFill>
+              </a:rPr>
+              <a:t>AURIS  ·  Hasan Arthur Altuntaş  ·  BM498 Mezuniyet Tezi</a:t>
+            </a:r>
+          </a:p>
+        </p:txBody>
+      </p:sp>
+      <p:sp>
+        <p:nvSpPr>
+          <p:cNvPr id="22" name="TextBox 21"/>
+          <p:cNvSpPr txBox="1"/>
+          <p:nvPr/>
+        </p:nvSpPr>
+        <p:spPr>
+          <a:xfrm>
+            <a:off x="8595360" y="6510528"/>
+            <a:ext cx="3200400" cy="301752"/>
+          </a:xfrm>
+          <a:prstGeom prst="rect">
+            <a:avLst/>
+          </a:prstGeom>
+          <a:noFill/>
+        </p:spPr>
+        <p:txBody>
+          <a:bodyPr wrap="square">
+            <a:spAutoFit/>
+          </a:bodyPr>
+          <a:lstStyle/>
+          <a:p>
+            <a:pPr algn="r"/>
+            <a:r>
+              <a:rPr sz="900" b="0" i="0">
+                <a:solidFill>
+                  <a:srgbClr val="66707A"/>
+                </a:solidFill>
+              </a:rPr>
+              <a:t>Düzce Üniversitesi · 2025-2026</a:t>
             </a:r>
           </a:p>
         </p:txBody>
@@ -4246,7 +5510,7 @@
         <p:spPr>
           <a:xfrm>
             <a:off x="0" y="0"/>
-            <a:ext cx="12188952" cy="1417320"/>
+            <a:ext cx="12188952" cy="1371600"/>
           </a:xfrm>
           <a:prstGeom prst="rect">
             <a:avLst/>
@@ -4282,59 +5546,23 @@
       </p:sp>
       <p:sp>
         <p:nvSpPr>
-          <p:cNvPr id="3" name="TextBox 2"/>
-          <p:cNvSpPr txBox="1"/>
-          <p:nvPr/>
-        </p:nvSpPr>
-        <p:spPr>
-          <a:xfrm>
-            <a:off x="320040" y="91440"/>
-            <a:ext cx="11521440" cy="822960"/>
-          </a:xfrm>
-          <a:prstGeom prst="rect">
-            <a:avLst/>
-          </a:prstGeom>
-          <a:noFill/>
-        </p:spPr>
-        <p:txBody>
-          <a:bodyPr wrap="square">
-            <a:spAutoFit/>
-          </a:bodyPr>
-          <a:lstStyle/>
-          <a:p>
-            <a:pPr algn="l"/>
-            <a:r>
-              <a:rPr sz="2500" b="1">
-                <a:solidFill>
-                  <a:srgbClr val="FFFFFF"/>
-                </a:solidFill>
-              </a:rPr>
-              <a:t>Beklenen Çıktılar</a:t>
-            </a:r>
-          </a:p>
-        </p:txBody>
-      </p:sp>
-      <p:sp>
-        <p:nvSpPr>
-          <p:cNvPr id="4" name="Rectangle 3"/>
+          <p:cNvPr id="3" name="Rectangle 2"/>
           <p:cNvSpPr/>
           <p:nvPr/>
         </p:nvSpPr>
         <p:spPr>
           <a:xfrm>
-            <a:off x="365760" y="1600200"/>
-            <a:ext cx="11430000" cy="1051560"/>
+            <a:off x="0" y="1371600"/>
+            <a:ext cx="12188952" cy="54864"/>
           </a:xfrm>
           <a:prstGeom prst="rect">
             <a:avLst/>
           </a:prstGeom>
           <a:solidFill>
-            <a:srgbClr val="FFFFFF"/>
+            <a:srgbClr val="E0A800"/>
           </a:solidFill>
           <a:ln>
-            <a:solidFill>
-              <a:srgbClr val="007A87"/>
-            </a:solidFill>
+            <a:noFill/>
           </a:ln>
         </p:spPr>
         <p:style>
@@ -4361,14 +5589,14 @@
       </p:sp>
       <p:sp>
         <p:nvSpPr>
-          <p:cNvPr id="5" name="TextBox 4"/>
+          <p:cNvPr id="4" name="TextBox 3"/>
           <p:cNvSpPr txBox="1"/>
           <p:nvPr/>
         </p:nvSpPr>
         <p:spPr>
           <a:xfrm>
-            <a:off x="548640" y="1709928"/>
-            <a:ext cx="3200400" cy="457200"/>
+            <a:off x="365760" y="109728"/>
+            <a:ext cx="11430000" cy="320040"/>
           </a:xfrm>
           <a:prstGeom prst="rect">
             <a:avLst/>
@@ -4383,26 +5611,26 @@
           <a:p>
             <a:pPr algn="l"/>
             <a:r>
-              <a:rPr sz="1500" b="1">
-                <a:solidFill>
-                  <a:srgbClr val="0D2B55"/>
-                </a:solidFill>
-              </a:rPr>
-              <a:t>1.  Tespit Sistemi</a:t>
-            </a:r>
-          </a:p>
-        </p:txBody>
-      </p:sp>
-      <p:sp>
-        <p:nvSpPr>
-          <p:cNvPr id="6" name="TextBox 5"/>
+              <a:rPr sz="1100" b="1" i="0">
+                <a:solidFill>
+                  <a:srgbClr val="E0A800"/>
+                </a:solidFill>
+              </a:rPr>
+              <a:t>PROJE YÖNETIMI</a:t>
+            </a:r>
+          </a:p>
+        </p:txBody>
+      </p:sp>
+      <p:sp>
+        <p:nvSpPr>
+          <p:cNvPr id="5" name="TextBox 4"/>
           <p:cNvSpPr txBox="1"/>
           <p:nvPr/>
         </p:nvSpPr>
         <p:spPr>
           <a:xfrm>
-            <a:off x="3931920" y="1709928"/>
-            <a:ext cx="7680960" cy="822960"/>
+            <a:off x="365760" y="402336"/>
+            <a:ext cx="11430000" cy="640080"/>
           </a:xfrm>
           <a:prstGeom prst="rect">
             <a:avLst/>
@@ -4417,37 +5645,103 @@
           <a:p>
             <a:pPr algn="l"/>
             <a:r>
-              <a:rPr sz="1400" b="0">
-                <a:solidFill>
-                  <a:srgbClr val="333333"/>
-                </a:solidFill>
-              </a:rPr>
-              <a:t>Uçtan uca LightGBM tabanlı, 47 öznitelikli sınıflandırıcı</a:t>
-            </a:r>
-          </a:p>
-        </p:txBody>
-      </p:sp>
-      <p:sp>
-        <p:nvSpPr>
-          <p:cNvPr id="7" name="Rectangle 6"/>
+              <a:rPr sz="2400" b="1" i="0">
+                <a:solidFill>
+                  <a:srgbClr val="FFFFFF"/>
+                </a:solidFill>
+              </a:rPr>
+              <a:t>Çalışma Planı ve Risk Yönetimi</a:t>
+            </a:r>
+          </a:p>
+        </p:txBody>
+      </p:sp>
+      <p:sp>
+        <p:nvSpPr>
+          <p:cNvPr id="6" name="TextBox 5"/>
+          <p:cNvSpPr txBox="1"/>
+          <p:nvPr/>
+        </p:nvSpPr>
+        <p:spPr>
+          <a:xfrm>
+            <a:off x="365760" y="1508760"/>
+            <a:ext cx="7315200" cy="365760"/>
+          </a:xfrm>
+          <a:prstGeom prst="rect">
+            <a:avLst/>
+          </a:prstGeom>
+          <a:noFill/>
+        </p:spPr>
+        <p:txBody>
+          <a:bodyPr wrap="square">
+            <a:spAutoFit/>
+          </a:bodyPr>
+          <a:lstStyle/>
+          <a:p>
+            <a:pPr algn="l"/>
+            <a:r>
+              <a:rPr sz="1400" b="1" i="0">
+                <a:solidFill>
+                  <a:srgbClr val="0D2B55"/>
+                </a:solidFill>
+              </a:rPr>
+              <a:t>10 Haftalık Zaman Planı</a:t>
+            </a:r>
+          </a:p>
+        </p:txBody>
+      </p:sp>
+      <p:sp>
+        <p:nvSpPr>
+          <p:cNvPr id="7" name="TextBox 6"/>
+          <p:cNvSpPr txBox="1"/>
+          <p:nvPr/>
+        </p:nvSpPr>
+        <p:spPr>
+          <a:xfrm>
+            <a:off x="365760" y="2011680"/>
+            <a:ext cx="2834640" cy="457200"/>
+          </a:xfrm>
+          <a:prstGeom prst="rect">
+            <a:avLst/>
+          </a:prstGeom>
+          <a:noFill/>
+        </p:spPr>
+        <p:txBody>
+          <a:bodyPr wrap="square" anchor="ctr">
+            <a:spAutoFit/>
+          </a:bodyPr>
+          <a:lstStyle/>
+          <a:p>
+            <a:pPr algn="l"/>
+            <a:r>
+              <a:rPr sz="1150" b="0" i="0">
+                <a:solidFill>
+                  <a:srgbClr val="2A2A2A"/>
+                </a:solidFill>
+              </a:rPr>
+              <a:t>Veri toplama ve ön işleme</a:t>
+            </a:r>
+          </a:p>
+        </p:txBody>
+      </p:sp>
+      <p:sp>
+        <p:nvSpPr>
+          <p:cNvPr id="8" name="Rectangle 7"/>
           <p:cNvSpPr/>
           <p:nvPr/>
         </p:nvSpPr>
         <p:spPr>
           <a:xfrm>
-            <a:off x="365760" y="2788920"/>
-            <a:ext cx="11430000" cy="1051560"/>
+            <a:off x="3291840" y="2066544"/>
+            <a:ext cx="1627632" cy="347472"/>
           </a:xfrm>
           <a:prstGeom prst="rect">
             <a:avLst/>
           </a:prstGeom>
           <a:solidFill>
-            <a:srgbClr val="FFFFFF"/>
+            <a:srgbClr val="007A87"/>
           </a:solidFill>
           <a:ln>
-            <a:solidFill>
-              <a:srgbClr val="007A87"/>
-            </a:solidFill>
+            <a:noFill/>
           </a:ln>
         </p:spPr>
         <p:style>
@@ -4474,14 +5768,14 @@
       </p:sp>
       <p:sp>
         <p:nvSpPr>
-          <p:cNvPr id="8" name="TextBox 7"/>
+          <p:cNvPr id="9" name="TextBox 8"/>
           <p:cNvSpPr txBox="1"/>
           <p:nvPr/>
         </p:nvSpPr>
         <p:spPr>
           <a:xfrm>
-            <a:off x="548640" y="2898648"/>
-            <a:ext cx="3200400" cy="457200"/>
+            <a:off x="3291840" y="2084832"/>
+            <a:ext cx="1627632" cy="310896"/>
           </a:xfrm>
           <a:prstGeom prst="rect">
             <a:avLst/>
@@ -4489,33 +5783,33 @@
           <a:noFill/>
         </p:spPr>
         <p:txBody>
-          <a:bodyPr wrap="square">
+          <a:bodyPr wrap="square" anchor="ctr">
             <a:spAutoFit/>
           </a:bodyPr>
           <a:lstStyle/>
           <a:p>
-            <a:pPr algn="l"/>
-            <a:r>
-              <a:rPr sz="1500" b="1">
-                <a:solidFill>
-                  <a:srgbClr val="0D2B55"/>
-                </a:solidFill>
-              </a:rPr>
-              <a:t>2.  Açıklanabilirlik</a:t>
-            </a:r>
-          </a:p>
-        </p:txBody>
-      </p:sp>
-      <p:sp>
-        <p:nvSpPr>
-          <p:cNvPr id="9" name="TextBox 8"/>
+            <a:pPr algn="ctr"/>
+            <a:r>
+              <a:rPr sz="1000" b="1" i="0">
+                <a:solidFill>
+                  <a:srgbClr val="FFFFFF"/>
+                </a:solidFill>
+              </a:rPr>
+              <a:t>H1-2</a:t>
+            </a:r>
+          </a:p>
+        </p:txBody>
+      </p:sp>
+      <p:sp>
+        <p:nvSpPr>
+          <p:cNvPr id="10" name="TextBox 9"/>
           <p:cNvSpPr txBox="1"/>
           <p:nvPr/>
         </p:nvSpPr>
         <p:spPr>
           <a:xfrm>
-            <a:off x="3931920" y="2898648"/>
-            <a:ext cx="7680960" cy="822960"/>
+            <a:off x="365760" y="2578608"/>
+            <a:ext cx="2834640" cy="457200"/>
           </a:xfrm>
           <a:prstGeom prst="rect">
             <a:avLst/>
@@ -4523,44 +5817,42 @@
           <a:noFill/>
         </p:spPr>
         <p:txBody>
-          <a:bodyPr wrap="square">
+          <a:bodyPr wrap="square" anchor="ctr">
             <a:spAutoFit/>
           </a:bodyPr>
           <a:lstStyle/>
           <a:p>
             <a:pPr algn="l"/>
             <a:r>
-              <a:rPr sz="1400" b="0">
-                <a:solidFill>
-                  <a:srgbClr val="333333"/>
-                </a:solidFill>
-              </a:rPr>
-              <a:t>SHAP/TreeSHAP ile her kararın yorumlanabilmesi</a:t>
-            </a:r>
-          </a:p>
-        </p:txBody>
-      </p:sp>
-      <p:sp>
-        <p:nvSpPr>
-          <p:cNvPr id="10" name="Rectangle 9"/>
+              <a:rPr sz="1150" b="0" i="0">
+                <a:solidFill>
+                  <a:srgbClr val="2A2A2A"/>
+                </a:solidFill>
+              </a:rPr>
+              <a:t>Öznitelik mühendisliği</a:t>
+            </a:r>
+          </a:p>
+        </p:txBody>
+      </p:sp>
+      <p:sp>
+        <p:nvSpPr>
+          <p:cNvPr id="11" name="Rectangle 10"/>
           <p:cNvSpPr/>
           <p:nvPr/>
         </p:nvSpPr>
         <p:spPr>
           <a:xfrm>
-            <a:off x="365760" y="3977639"/>
-            <a:ext cx="11430000" cy="1051560"/>
+            <a:off x="4919472" y="2633472"/>
+            <a:ext cx="1627632" cy="347472"/>
           </a:xfrm>
           <a:prstGeom prst="rect">
             <a:avLst/>
           </a:prstGeom>
           <a:solidFill>
-            <a:srgbClr val="FFFFFF"/>
+            <a:srgbClr val="007A87"/>
           </a:solidFill>
           <a:ln>
-            <a:solidFill>
-              <a:srgbClr val="007A87"/>
-            </a:solidFill>
+            <a:noFill/>
           </a:ln>
         </p:spPr>
         <p:style>
@@ -4587,14 +5879,14 @@
       </p:sp>
       <p:sp>
         <p:nvSpPr>
-          <p:cNvPr id="11" name="TextBox 10"/>
+          <p:cNvPr id="12" name="TextBox 11"/>
           <p:cNvSpPr txBox="1"/>
           <p:nvPr/>
         </p:nvSpPr>
         <p:spPr>
           <a:xfrm>
-            <a:off x="548640" y="4087368"/>
-            <a:ext cx="3200400" cy="457200"/>
+            <a:off x="4919472" y="2651760"/>
+            <a:ext cx="1627632" cy="310896"/>
           </a:xfrm>
           <a:prstGeom prst="rect">
             <a:avLst/>
@@ -4602,33 +5894,33 @@
           <a:noFill/>
         </p:spPr>
         <p:txBody>
-          <a:bodyPr wrap="square">
+          <a:bodyPr wrap="square" anchor="ctr">
             <a:spAutoFit/>
           </a:bodyPr>
           <a:lstStyle/>
           <a:p>
-            <a:pPr algn="l"/>
-            <a:r>
-              <a:rPr sz="1500" b="1">
-                <a:solidFill>
-                  <a:srgbClr val="0D2B55"/>
-                </a:solidFill>
-              </a:rPr>
-              <a:t>3.  Akademik Yayın</a:t>
-            </a:r>
-          </a:p>
-        </p:txBody>
-      </p:sp>
-      <p:sp>
-        <p:nvSpPr>
-          <p:cNvPr id="12" name="TextBox 11"/>
+            <a:pPr algn="ctr"/>
+            <a:r>
+              <a:rPr sz="1000" b="1" i="0">
+                <a:solidFill>
+                  <a:srgbClr val="FFFFFF"/>
+                </a:solidFill>
+              </a:rPr>
+              <a:t>H3-4</a:t>
+            </a:r>
+          </a:p>
+        </p:txBody>
+      </p:sp>
+      <p:sp>
+        <p:nvSpPr>
+          <p:cNvPr id="13" name="TextBox 12"/>
           <p:cNvSpPr txBox="1"/>
           <p:nvPr/>
         </p:nvSpPr>
         <p:spPr>
           <a:xfrm>
-            <a:off x="3931920" y="4087368"/>
-            <a:ext cx="7680960" cy="822960"/>
+            <a:off x="365760" y="3145536"/>
+            <a:ext cx="2834640" cy="457200"/>
           </a:xfrm>
           <a:prstGeom prst="rect">
             <a:avLst/>
@@ -4636,44 +5928,42 @@
           <a:noFill/>
         </p:spPr>
         <p:txBody>
-          <a:bodyPr wrap="square">
+          <a:bodyPr wrap="square" anchor="ctr">
             <a:spAutoFit/>
           </a:bodyPr>
           <a:lstStyle/>
           <a:p>
             <a:pPr algn="l"/>
             <a:r>
-              <a:rPr sz="1400" b="0">
-                <a:solidFill>
-                  <a:srgbClr val="333333"/>
-                </a:solidFill>
-              </a:rPr>
-              <a:t>GUJSA'ya gönderilmek üzere hazırlanan makale</a:t>
-            </a:r>
-          </a:p>
-        </p:txBody>
-      </p:sp>
-      <p:sp>
-        <p:nvSpPr>
-          <p:cNvPr id="13" name="Rectangle 12"/>
+              <a:rPr sz="1150" b="0" i="0">
+                <a:solidFill>
+                  <a:srgbClr val="2A2A2A"/>
+                </a:solidFill>
+              </a:rPr>
+              <a:t>Model eğitimi ve çapraz doğrulama</a:t>
+            </a:r>
+          </a:p>
+        </p:txBody>
+      </p:sp>
+      <p:sp>
+        <p:nvSpPr>
+          <p:cNvPr id="14" name="Rectangle 13"/>
           <p:cNvSpPr/>
           <p:nvPr/>
         </p:nvSpPr>
         <p:spPr>
           <a:xfrm>
-            <a:off x="365760" y="5166360"/>
-            <a:ext cx="11430000" cy="1051560"/>
+            <a:off x="6547104" y="3200400"/>
+            <a:ext cx="1627632" cy="347472"/>
           </a:xfrm>
           <a:prstGeom prst="rect">
             <a:avLst/>
           </a:prstGeom>
           <a:solidFill>
-            <a:srgbClr val="FFFFFF"/>
+            <a:srgbClr val="0D2B55"/>
           </a:solidFill>
           <a:ln>
-            <a:solidFill>
-              <a:srgbClr val="007A87"/>
-            </a:solidFill>
+            <a:noFill/>
           </a:ln>
         </p:spPr>
         <p:style>
@@ -4700,14 +5990,270 @@
       </p:sp>
       <p:sp>
         <p:nvSpPr>
-          <p:cNvPr id="14" name="TextBox 13"/>
+          <p:cNvPr id="15" name="TextBox 14"/>
           <p:cNvSpPr txBox="1"/>
           <p:nvPr/>
         </p:nvSpPr>
         <p:spPr>
           <a:xfrm>
-            <a:off x="548640" y="5276088"/>
-            <a:ext cx="3200400" cy="457200"/>
+            <a:off x="6547104" y="3218688"/>
+            <a:ext cx="1627632" cy="310896"/>
+          </a:xfrm>
+          <a:prstGeom prst="rect">
+            <a:avLst/>
+          </a:prstGeom>
+          <a:noFill/>
+        </p:spPr>
+        <p:txBody>
+          <a:bodyPr wrap="square" anchor="ctr">
+            <a:spAutoFit/>
+          </a:bodyPr>
+          <a:lstStyle/>
+          <a:p>
+            <a:pPr algn="ctr"/>
+            <a:r>
+              <a:rPr sz="1000" b="1" i="0">
+                <a:solidFill>
+                  <a:srgbClr val="FFFFFF"/>
+                </a:solidFill>
+              </a:rPr>
+              <a:t>H5-6</a:t>
+            </a:r>
+          </a:p>
+        </p:txBody>
+      </p:sp>
+      <p:sp>
+        <p:nvSpPr>
+          <p:cNvPr id="16" name="TextBox 15"/>
+          <p:cNvSpPr txBox="1"/>
+          <p:nvPr/>
+        </p:nvSpPr>
+        <p:spPr>
+          <a:xfrm>
+            <a:off x="365760" y="3712464"/>
+            <a:ext cx="2834640" cy="457200"/>
+          </a:xfrm>
+          <a:prstGeom prst="rect">
+            <a:avLst/>
+          </a:prstGeom>
+          <a:noFill/>
+        </p:spPr>
+        <p:txBody>
+          <a:bodyPr wrap="square" anchor="ctr">
+            <a:spAutoFit/>
+          </a:bodyPr>
+          <a:lstStyle/>
+          <a:p>
+            <a:pPr algn="l"/>
+            <a:r>
+              <a:rPr sz="1150" b="0" i="0">
+                <a:solidFill>
+                  <a:srgbClr val="2A2A2A"/>
+                </a:solidFill>
+              </a:rPr>
+              <a:t>Değerlendirme ve SHAP analizi</a:t>
+            </a:r>
+          </a:p>
+        </p:txBody>
+      </p:sp>
+      <p:sp>
+        <p:nvSpPr>
+          <p:cNvPr id="17" name="Rectangle 16"/>
+          <p:cNvSpPr/>
+          <p:nvPr/>
+        </p:nvSpPr>
+        <p:spPr>
+          <a:xfrm>
+            <a:off x="8174736" y="3767328"/>
+            <a:ext cx="1627632" cy="347472"/>
+          </a:xfrm>
+          <a:prstGeom prst="rect">
+            <a:avLst/>
+          </a:prstGeom>
+          <a:solidFill>
+            <a:srgbClr val="0D2B55"/>
+          </a:solidFill>
+          <a:ln>
+            <a:noFill/>
+          </a:ln>
+        </p:spPr>
+        <p:style>
+          <a:lnRef idx="1">
+            <a:schemeClr val="accent1"/>
+          </a:lnRef>
+          <a:fillRef idx="3">
+            <a:schemeClr val="accent1"/>
+          </a:fillRef>
+          <a:effectRef idx="2">
+            <a:schemeClr val="accent1"/>
+          </a:effectRef>
+          <a:fontRef idx="minor">
+            <a:schemeClr val="lt1"/>
+          </a:fontRef>
+        </p:style>
+        <p:txBody>
+          <a:bodyPr rtlCol="0" anchor="ctr"/>
+          <a:lstStyle/>
+          <a:p>
+            <a:pPr algn="ctr"/>
+          </a:p>
+        </p:txBody>
+      </p:sp>
+      <p:sp>
+        <p:nvSpPr>
+          <p:cNvPr id="18" name="TextBox 17"/>
+          <p:cNvSpPr txBox="1"/>
+          <p:nvPr/>
+        </p:nvSpPr>
+        <p:spPr>
+          <a:xfrm>
+            <a:off x="8174736" y="3785616"/>
+            <a:ext cx="1627632" cy="310896"/>
+          </a:xfrm>
+          <a:prstGeom prst="rect">
+            <a:avLst/>
+          </a:prstGeom>
+          <a:noFill/>
+        </p:spPr>
+        <p:txBody>
+          <a:bodyPr wrap="square" anchor="ctr">
+            <a:spAutoFit/>
+          </a:bodyPr>
+          <a:lstStyle/>
+          <a:p>
+            <a:pPr algn="ctr"/>
+            <a:r>
+              <a:rPr sz="1000" b="1" i="0">
+                <a:solidFill>
+                  <a:srgbClr val="FFFFFF"/>
+                </a:solidFill>
+              </a:rPr>
+              <a:t>H7-8</a:t>
+            </a:r>
+          </a:p>
+        </p:txBody>
+      </p:sp>
+      <p:sp>
+        <p:nvSpPr>
+          <p:cNvPr id="19" name="TextBox 18"/>
+          <p:cNvSpPr txBox="1"/>
+          <p:nvPr/>
+        </p:nvSpPr>
+        <p:spPr>
+          <a:xfrm>
+            <a:off x="365760" y="4279392"/>
+            <a:ext cx="2834640" cy="457200"/>
+          </a:xfrm>
+          <a:prstGeom prst="rect">
+            <a:avLst/>
+          </a:prstGeom>
+          <a:noFill/>
+        </p:spPr>
+        <p:txBody>
+          <a:bodyPr wrap="square" anchor="ctr">
+            <a:spAutoFit/>
+          </a:bodyPr>
+          <a:lstStyle/>
+          <a:p>
+            <a:pPr algn="l"/>
+            <a:r>
+              <a:rPr sz="1150" b="0" i="0">
+                <a:solidFill>
+                  <a:srgbClr val="2A2A2A"/>
+                </a:solidFill>
+              </a:rPr>
+              <a:t>Yazım, sunum ve teslim</a:t>
+            </a:r>
+          </a:p>
+        </p:txBody>
+      </p:sp>
+      <p:sp>
+        <p:nvSpPr>
+          <p:cNvPr id="20" name="Rectangle 19"/>
+          <p:cNvSpPr/>
+          <p:nvPr/>
+        </p:nvSpPr>
+        <p:spPr>
+          <a:xfrm>
+            <a:off x="9802368" y="4334255"/>
+            <a:ext cx="1627632" cy="347472"/>
+          </a:xfrm>
+          <a:prstGeom prst="rect">
+            <a:avLst/>
+          </a:prstGeom>
+          <a:solidFill>
+            <a:srgbClr val="E0A800"/>
+          </a:solidFill>
+          <a:ln>
+            <a:noFill/>
+          </a:ln>
+        </p:spPr>
+        <p:style>
+          <a:lnRef idx="1">
+            <a:schemeClr val="accent1"/>
+          </a:lnRef>
+          <a:fillRef idx="3">
+            <a:schemeClr val="accent1"/>
+          </a:fillRef>
+          <a:effectRef idx="2">
+            <a:schemeClr val="accent1"/>
+          </a:effectRef>
+          <a:fontRef idx="minor">
+            <a:schemeClr val="lt1"/>
+          </a:fontRef>
+        </p:style>
+        <p:txBody>
+          <a:bodyPr rtlCol="0" anchor="ctr"/>
+          <a:lstStyle/>
+          <a:p>
+            <a:pPr algn="ctr"/>
+          </a:p>
+        </p:txBody>
+      </p:sp>
+      <p:sp>
+        <p:nvSpPr>
+          <p:cNvPr id="21" name="TextBox 20"/>
+          <p:cNvSpPr txBox="1"/>
+          <p:nvPr/>
+        </p:nvSpPr>
+        <p:spPr>
+          <a:xfrm>
+            <a:off x="9802368" y="4352544"/>
+            <a:ext cx="1627632" cy="310896"/>
+          </a:xfrm>
+          <a:prstGeom prst="rect">
+            <a:avLst/>
+          </a:prstGeom>
+          <a:noFill/>
+        </p:spPr>
+        <p:txBody>
+          <a:bodyPr wrap="square" anchor="ctr">
+            <a:spAutoFit/>
+          </a:bodyPr>
+          <a:lstStyle/>
+          <a:p>
+            <a:pPr algn="ctr"/>
+            <a:r>
+              <a:rPr sz="1000" b="1" i="0">
+                <a:solidFill>
+                  <a:srgbClr val="FFFFFF"/>
+                </a:solidFill>
+              </a:rPr>
+              <a:t>H9-10</a:t>
+            </a:r>
+          </a:p>
+        </p:txBody>
+      </p:sp>
+      <p:sp>
+        <p:nvSpPr>
+          <p:cNvPr id="22" name="TextBox 21"/>
+          <p:cNvSpPr txBox="1"/>
+          <p:nvPr/>
+        </p:nvSpPr>
+        <p:spPr>
+          <a:xfrm>
+            <a:off x="365760" y="5029200"/>
+            <a:ext cx="11430000" cy="365760"/>
           </a:xfrm>
           <a:prstGeom prst="rect">
             <a:avLst/>
@@ -4722,26 +6268,71 @@
           <a:p>
             <a:pPr algn="l"/>
             <a:r>
-              <a:rPr sz="1500" b="1">
+              <a:rPr sz="1400" b="1" i="0">
                 <a:solidFill>
                   <a:srgbClr val="0D2B55"/>
                 </a:solidFill>
               </a:rPr>
-              <a:t>4.  Açık Kaynak Kod</a:t>
-            </a:r>
-          </a:p>
-        </p:txBody>
-      </p:sp>
-      <p:sp>
-        <p:nvSpPr>
-          <p:cNvPr id="15" name="TextBox 14"/>
+              <a:t>Risk Analizi ve Önlemler</a:t>
+            </a:r>
+          </a:p>
+        </p:txBody>
+      </p:sp>
+      <p:sp>
+        <p:nvSpPr>
+          <p:cNvPr id="23" name="Rectangle 22"/>
+          <p:cNvSpPr/>
+          <p:nvPr/>
+        </p:nvSpPr>
+        <p:spPr>
+          <a:xfrm>
+            <a:off x="365760" y="5440680"/>
+            <a:ext cx="3749039" cy="914400"/>
+          </a:xfrm>
+          <a:prstGeom prst="rect">
+            <a:avLst/>
+          </a:prstGeom>
+          <a:solidFill>
+            <a:srgbClr val="FFFFFF"/>
+          </a:solidFill>
+          <a:ln w="15240">
+            <a:solidFill>
+              <a:srgbClr val="B52A2A"/>
+            </a:solidFill>
+          </a:ln>
+        </p:spPr>
+        <p:style>
+          <a:lnRef idx="1">
+            <a:schemeClr val="accent1"/>
+          </a:lnRef>
+          <a:fillRef idx="3">
+            <a:schemeClr val="accent1"/>
+          </a:fillRef>
+          <a:effectRef idx="2">
+            <a:schemeClr val="accent1"/>
+          </a:effectRef>
+          <a:fontRef idx="minor">
+            <a:schemeClr val="lt1"/>
+          </a:fontRef>
+        </p:style>
+        <p:txBody>
+          <a:bodyPr rtlCol="0" anchor="ctr"/>
+          <a:lstStyle/>
+          <a:p>
+            <a:pPr algn="ctr"/>
+          </a:p>
+        </p:txBody>
+      </p:sp>
+      <p:sp>
+        <p:nvSpPr>
+          <p:cNvPr id="24" name="TextBox 23"/>
           <p:cNvSpPr txBox="1"/>
           <p:nvPr/>
         </p:nvSpPr>
         <p:spPr>
           <a:xfrm>
-            <a:off x="3931920" y="5276088"/>
-            <a:ext cx="7680960" cy="822960"/>
+            <a:off x="475488" y="5513832"/>
+            <a:ext cx="3529583" cy="320040"/>
           </a:xfrm>
           <a:prstGeom prst="rect">
             <a:avLst/>
@@ -4756,26 +6347,26 @@
           <a:p>
             <a:pPr algn="l"/>
             <a:r>
-              <a:rPr sz="1400" b="0">
-                <a:solidFill>
-                  <a:srgbClr val="333333"/>
-                </a:solidFill>
-              </a:rPr>
-              <a:t>Backend + model — teslim paketiyle birlikte</a:t>
-            </a:r>
-          </a:p>
-        </p:txBody>
-      </p:sp>
-      <p:sp>
-        <p:nvSpPr>
-          <p:cNvPr id="16" name="TextBox 15"/>
+              <a:rPr sz="1200" b="1" i="0">
+                <a:solidFill>
+                  <a:srgbClr val="B52A2A"/>
+                </a:solidFill>
+              </a:rPr>
+              <a:t>⚠  Sınıf dengesizliği</a:t>
+            </a:r>
+          </a:p>
+        </p:txBody>
+      </p:sp>
+      <p:sp>
+        <p:nvSpPr>
+          <p:cNvPr id="25" name="TextBox 24"/>
           <p:cNvSpPr txBox="1"/>
           <p:nvPr/>
         </p:nvSpPr>
         <p:spPr>
           <a:xfrm>
-            <a:off x="0" y="6510528"/>
-            <a:ext cx="12188952" cy="301752"/>
+            <a:off x="475488" y="5870448"/>
+            <a:ext cx="3529583" cy="457200"/>
           </a:xfrm>
           <a:prstGeom prst="rect">
             <a:avLst/>
@@ -4788,14 +6379,308 @@
           </a:bodyPr>
           <a:lstStyle/>
           <a:p>
+            <a:pPr algn="l"/>
+            <a:r>
+              <a:rPr sz="1050" b="0" i="0">
+                <a:solidFill>
+                  <a:srgbClr val="2A2A2A"/>
+                </a:solidFill>
+              </a:rPr>
+              <a:t>class_weight='balanced', is_unbalance=True</a:t>
+            </a:r>
+          </a:p>
+        </p:txBody>
+      </p:sp>
+      <p:sp>
+        <p:nvSpPr>
+          <p:cNvPr id="26" name="Rectangle 25"/>
+          <p:cNvSpPr/>
+          <p:nvPr/>
+        </p:nvSpPr>
+        <p:spPr>
+          <a:xfrm>
+            <a:off x="4206240" y="5440680"/>
+            <a:ext cx="3749039" cy="914400"/>
+          </a:xfrm>
+          <a:prstGeom prst="rect">
+            <a:avLst/>
+          </a:prstGeom>
+          <a:solidFill>
+            <a:srgbClr val="FFFFFF"/>
+          </a:solidFill>
+          <a:ln w="15240">
+            <a:solidFill>
+              <a:srgbClr val="B52A2A"/>
+            </a:solidFill>
+          </a:ln>
+        </p:spPr>
+        <p:style>
+          <a:lnRef idx="1">
+            <a:schemeClr val="accent1"/>
+          </a:lnRef>
+          <a:fillRef idx="3">
+            <a:schemeClr val="accent1"/>
+          </a:fillRef>
+          <a:effectRef idx="2">
+            <a:schemeClr val="accent1"/>
+          </a:effectRef>
+          <a:fontRef idx="minor">
+            <a:schemeClr val="lt1"/>
+          </a:fontRef>
+        </p:style>
+        <p:txBody>
+          <a:bodyPr rtlCol="0" anchor="ctr"/>
+          <a:lstStyle/>
+          <a:p>
             <a:pPr algn="ctr"/>
-            <a:r>
-              <a:rPr sz="900" b="0">
-                <a:solidFill>
-                  <a:srgbClr val="8899AA"/>
-                </a:solidFill>
-              </a:rPr>
-              <a:t>Hasan Arthur Altuntaş  |  BM498  |  Düzce Üniversitesi  |  2025-2026</a:t>
+          </a:p>
+        </p:txBody>
+      </p:sp>
+      <p:sp>
+        <p:nvSpPr>
+          <p:cNvPr id="27" name="TextBox 26"/>
+          <p:cNvSpPr txBox="1"/>
+          <p:nvPr/>
+        </p:nvSpPr>
+        <p:spPr>
+          <a:xfrm>
+            <a:off x="4315968" y="5513832"/>
+            <a:ext cx="3529583" cy="320040"/>
+          </a:xfrm>
+          <a:prstGeom prst="rect">
+            <a:avLst/>
+          </a:prstGeom>
+          <a:noFill/>
+        </p:spPr>
+        <p:txBody>
+          <a:bodyPr wrap="square">
+            <a:spAutoFit/>
+          </a:bodyPr>
+          <a:lstStyle/>
+          <a:p>
+            <a:pPr algn="l"/>
+            <a:r>
+              <a:rPr sz="1200" b="1" i="0">
+                <a:solidFill>
+                  <a:srgbClr val="B52A2A"/>
+                </a:solidFill>
+              </a:rPr>
+              <a:t>⚠  Aşırı uyum (overfitting)</a:t>
+            </a:r>
+          </a:p>
+        </p:txBody>
+      </p:sp>
+      <p:sp>
+        <p:nvSpPr>
+          <p:cNvPr id="28" name="TextBox 27"/>
+          <p:cNvSpPr txBox="1"/>
+          <p:nvPr/>
+        </p:nvSpPr>
+        <p:spPr>
+          <a:xfrm>
+            <a:off x="4315968" y="5870448"/>
+            <a:ext cx="3529583" cy="457200"/>
+          </a:xfrm>
+          <a:prstGeom prst="rect">
+            <a:avLst/>
+          </a:prstGeom>
+          <a:noFill/>
+        </p:spPr>
+        <p:txBody>
+          <a:bodyPr wrap="square">
+            <a:spAutoFit/>
+          </a:bodyPr>
+          <a:lstStyle/>
+          <a:p>
+            <a:pPr algn="l"/>
+            <a:r>
+              <a:rPr sz="1050" b="0" i="0">
+                <a:solidFill>
+                  <a:srgbClr val="2A2A2A"/>
+                </a:solidFill>
+              </a:rPr>
+              <a:t>5-katlı CV, erken durdurma, düzenlileştirme</a:t>
+            </a:r>
+          </a:p>
+        </p:txBody>
+      </p:sp>
+      <p:sp>
+        <p:nvSpPr>
+          <p:cNvPr id="29" name="Rectangle 28"/>
+          <p:cNvSpPr/>
+          <p:nvPr/>
+        </p:nvSpPr>
+        <p:spPr>
+          <a:xfrm>
+            <a:off x="8046720" y="5440680"/>
+            <a:ext cx="3749039" cy="914400"/>
+          </a:xfrm>
+          <a:prstGeom prst="rect">
+            <a:avLst/>
+          </a:prstGeom>
+          <a:solidFill>
+            <a:srgbClr val="FFFFFF"/>
+          </a:solidFill>
+          <a:ln w="15240">
+            <a:solidFill>
+              <a:srgbClr val="B52A2A"/>
+            </a:solidFill>
+          </a:ln>
+        </p:spPr>
+        <p:style>
+          <a:lnRef idx="1">
+            <a:schemeClr val="accent1"/>
+          </a:lnRef>
+          <a:fillRef idx="3">
+            <a:schemeClr val="accent1"/>
+          </a:fillRef>
+          <a:effectRef idx="2">
+            <a:schemeClr val="accent1"/>
+          </a:effectRef>
+          <a:fontRef idx="minor">
+            <a:schemeClr val="lt1"/>
+          </a:fontRef>
+        </p:style>
+        <p:txBody>
+          <a:bodyPr rtlCol="0" anchor="ctr"/>
+          <a:lstStyle/>
+          <a:p>
+            <a:pPr algn="ctr"/>
+          </a:p>
+        </p:txBody>
+      </p:sp>
+      <p:sp>
+        <p:nvSpPr>
+          <p:cNvPr id="30" name="TextBox 29"/>
+          <p:cNvSpPr txBox="1"/>
+          <p:nvPr/>
+        </p:nvSpPr>
+        <p:spPr>
+          <a:xfrm>
+            <a:off x="8156448" y="5513832"/>
+            <a:ext cx="3529583" cy="320040"/>
+          </a:xfrm>
+          <a:prstGeom prst="rect">
+            <a:avLst/>
+          </a:prstGeom>
+          <a:noFill/>
+        </p:spPr>
+        <p:txBody>
+          <a:bodyPr wrap="square">
+            <a:spAutoFit/>
+          </a:bodyPr>
+          <a:lstStyle/>
+          <a:p>
+            <a:pPr algn="l"/>
+            <a:r>
+              <a:rPr sz="1200" b="1" i="0">
+                <a:solidFill>
+                  <a:srgbClr val="B52A2A"/>
+                </a:solidFill>
+              </a:rPr>
+              <a:t>⚠  Veri sızıntısı</a:t>
+            </a:r>
+          </a:p>
+        </p:txBody>
+      </p:sp>
+      <p:sp>
+        <p:nvSpPr>
+          <p:cNvPr id="31" name="TextBox 30"/>
+          <p:cNvSpPr txBox="1"/>
+          <p:nvPr/>
+        </p:nvSpPr>
+        <p:spPr>
+          <a:xfrm>
+            <a:off x="8156448" y="5870448"/>
+            <a:ext cx="3529583" cy="457200"/>
+          </a:xfrm>
+          <a:prstGeom prst="rect">
+            <a:avLst/>
+          </a:prstGeom>
+          <a:noFill/>
+        </p:spPr>
+        <p:txBody>
+          <a:bodyPr wrap="square">
+            <a:spAutoFit/>
+          </a:bodyPr>
+          <a:lstStyle/>
+          <a:p>
+            <a:pPr algn="l"/>
+            <a:r>
+              <a:rPr sz="1050" b="0" i="0">
+                <a:solidFill>
+                  <a:srgbClr val="2A2A2A"/>
+                </a:solidFill>
+              </a:rPr>
+              <a:t>StandardScaler her katta yalnız eğitim verisine fit</a:t>
+            </a:r>
+          </a:p>
+        </p:txBody>
+      </p:sp>
+      <p:sp>
+        <p:nvSpPr>
+          <p:cNvPr id="32" name="TextBox 31"/>
+          <p:cNvSpPr txBox="1"/>
+          <p:nvPr/>
+        </p:nvSpPr>
+        <p:spPr>
+          <a:xfrm>
+            <a:off x="365760" y="6510528"/>
+            <a:ext cx="8229600" cy="301752"/>
+          </a:xfrm>
+          <a:prstGeom prst="rect">
+            <a:avLst/>
+          </a:prstGeom>
+          <a:noFill/>
+        </p:spPr>
+        <p:txBody>
+          <a:bodyPr wrap="square">
+            <a:spAutoFit/>
+          </a:bodyPr>
+          <a:lstStyle/>
+          <a:p>
+            <a:pPr algn="l"/>
+            <a:r>
+              <a:rPr sz="900" b="0" i="0">
+                <a:solidFill>
+                  <a:srgbClr val="66707A"/>
+                </a:solidFill>
+              </a:rPr>
+              <a:t>AURIS  ·  Hasan Arthur Altuntaş  ·  BM498 Mezuniyet Tezi</a:t>
+            </a:r>
+          </a:p>
+        </p:txBody>
+      </p:sp>
+      <p:sp>
+        <p:nvSpPr>
+          <p:cNvPr id="33" name="TextBox 32"/>
+          <p:cNvSpPr txBox="1"/>
+          <p:nvPr/>
+        </p:nvSpPr>
+        <p:spPr>
+          <a:xfrm>
+            <a:off x="8595360" y="6510528"/>
+            <a:ext cx="3200400" cy="301752"/>
+          </a:xfrm>
+          <a:prstGeom prst="rect">
+            <a:avLst/>
+          </a:prstGeom>
+          <a:noFill/>
+        </p:spPr>
+        <p:txBody>
+          <a:bodyPr wrap="square">
+            <a:spAutoFit/>
+          </a:bodyPr>
+          <a:lstStyle/>
+          <a:p>
+            <a:pPr algn="r"/>
+            <a:r>
+              <a:rPr sz="900" b="0" i="0">
+                <a:solidFill>
+                  <a:srgbClr val="66707A"/>
+                </a:solidFill>
+              </a:rPr>
+              <a:t>Düzce Üniversitesi · 2025-2026</a:t>
             </a:r>
           </a:p>
         </p:txBody>
@@ -4893,7 +6778,7 @@
           <a:p>
             <a:pPr algn="l"/>
             <a:r>
-              <a:rPr sz="1100" b="0">
+              <a:rPr sz="1100" b="0" i="0">
                 <a:solidFill>
                   <a:srgbClr val="FFFFFF"/>
                 </a:solidFill>
@@ -4911,8 +6796,8 @@
         </p:nvSpPr>
         <p:spPr>
           <a:xfrm>
-            <a:off x="2286000" y="1005840"/>
-            <a:ext cx="7589520" cy="5394960"/>
+            <a:off x="2286000" y="960120"/>
+            <a:ext cx="7589520" cy="5440680"/>
           </a:xfrm>
           <a:prstGeom prst="rect">
             <a:avLst/>
@@ -4920,7 +6805,7 @@
           <a:solidFill>
             <a:srgbClr val="FFFFFF"/>
           </a:solidFill>
-          <a:ln>
+          <a:ln w="19050">
             <a:solidFill>
               <a:srgbClr val="007A87"/>
             </a:solidFill>
@@ -4956,8 +6841,8 @@
         </p:nvSpPr>
         <p:spPr>
           <a:xfrm>
-            <a:off x="2377440" y="1115568"/>
-            <a:ext cx="7406640" cy="548640"/>
+            <a:off x="2377440" y="1078992"/>
+            <a:ext cx="7406640" cy="502920"/>
           </a:xfrm>
           <a:prstGeom prst="rect">
             <a:avLst/>
@@ -4972,7 +6857,7 @@
           <a:p>
             <a:pPr algn="ctr"/>
             <a:r>
-              <a:rPr sz="1700" b="1">
+              <a:rPr sz="1700" b="1" i="0">
                 <a:solidFill>
                   <a:srgbClr val="0D2B55"/>
                 </a:solidFill>
@@ -4990,7 +6875,7 @@
         </p:nvSpPr>
         <p:spPr>
           <a:xfrm>
-            <a:off x="2377440" y="1691640"/>
+            <a:off x="2377440" y="1627632"/>
             <a:ext cx="7406640" cy="0"/>
           </a:xfrm>
           <a:prstGeom prst="rect">
@@ -5032,7 +6917,7 @@
         </p:nvSpPr>
         <p:spPr>
           <a:xfrm>
-            <a:off x="2468880" y="1874519"/>
+            <a:off x="2468880" y="1810512"/>
             <a:ext cx="2834640" cy="320040"/>
           </a:xfrm>
           <a:prstGeom prst="rect">
@@ -5048,7 +6933,7 @@
           <a:p>
             <a:pPr algn="l"/>
             <a:r>
-              <a:rPr sz="1200" b="1">
+              <a:rPr sz="1200" b="1" i="0">
                 <a:solidFill>
                   <a:srgbClr val="0D2B55"/>
                 </a:solidFill>
@@ -5066,7 +6951,7 @@
         </p:nvSpPr>
         <p:spPr>
           <a:xfrm>
-            <a:off x="5394960" y="1874519"/>
+            <a:off x="5394960" y="1810512"/>
             <a:ext cx="4297680" cy="320040"/>
           </a:xfrm>
           <a:prstGeom prst="rect">
@@ -5082,9 +6967,9 @@
           <a:p>
             <a:pPr algn="l"/>
             <a:r>
-              <a:rPr sz="1200" b="0">
-                <a:solidFill>
-                  <a:srgbClr val="333333"/>
+              <a:rPr sz="1200" b="0" i="0">
+                <a:solidFill>
+                  <a:srgbClr val="2A2A2A"/>
                 </a:solidFill>
               </a:rPr>
               <a:t>Hasan Arthur Altuntaş</a:t>
@@ -5100,7 +6985,7 @@
         </p:nvSpPr>
         <p:spPr>
           <a:xfrm>
-            <a:off x="5349240" y="2212848"/>
+            <a:off x="5349240" y="2148840"/>
             <a:ext cx="4343400" cy="0"/>
           </a:xfrm>
           <a:prstGeom prst="rect">
@@ -5142,7 +7027,7 @@
         </p:nvSpPr>
         <p:spPr>
           <a:xfrm>
-            <a:off x="2468880" y="2423160"/>
+            <a:off x="2468880" y="2377440"/>
             <a:ext cx="2834640" cy="320040"/>
           </a:xfrm>
           <a:prstGeom prst="rect">
@@ -5158,7 +7043,7 @@
           <a:p>
             <a:pPr algn="l"/>
             <a:r>
-              <a:rPr sz="1200" b="1">
+              <a:rPr sz="1200" b="1" i="0">
                 <a:solidFill>
                   <a:srgbClr val="0D2B55"/>
                 </a:solidFill>
@@ -5176,7 +7061,7 @@
         </p:nvSpPr>
         <p:spPr>
           <a:xfrm>
-            <a:off x="5394960" y="2423160"/>
+            <a:off x="5394960" y="2377440"/>
             <a:ext cx="4297680" cy="320040"/>
           </a:xfrm>
           <a:prstGeom prst="rect">
@@ -5192,9 +7077,9 @@
           <a:p>
             <a:pPr algn="l"/>
             <a:r>
-              <a:rPr sz="1200" b="0">
-                <a:solidFill>
-                  <a:srgbClr val="333333"/>
+              <a:rPr sz="1200" b="0" i="0">
+                <a:solidFill>
+                  <a:srgbClr val="2A2A2A"/>
                 </a:solidFill>
               </a:rPr>
               <a:t/>
@@ -5210,7 +7095,7 @@
         </p:nvSpPr>
         <p:spPr>
           <a:xfrm>
-            <a:off x="5349240" y="2761488"/>
+            <a:off x="5349240" y="2715768"/>
             <a:ext cx="4343400" cy="0"/>
           </a:xfrm>
           <a:prstGeom prst="rect">
@@ -5252,7 +7137,7 @@
         </p:nvSpPr>
         <p:spPr>
           <a:xfrm>
-            <a:off x="2468880" y="2971800"/>
+            <a:off x="2468880" y="2944368"/>
             <a:ext cx="2834640" cy="320040"/>
           </a:xfrm>
           <a:prstGeom prst="rect">
@@ -5268,7 +7153,7 @@
           <a:p>
             <a:pPr algn="l"/>
             <a:r>
-              <a:rPr sz="1200" b="1">
+              <a:rPr sz="1200" b="1" i="0">
                 <a:solidFill>
                   <a:srgbClr val="0D2B55"/>
                 </a:solidFill>
@@ -5286,7 +7171,7 @@
         </p:nvSpPr>
         <p:spPr>
           <a:xfrm>
-            <a:off x="5394960" y="2971800"/>
+            <a:off x="5394960" y="2944368"/>
             <a:ext cx="4297680" cy="320040"/>
           </a:xfrm>
           <a:prstGeom prst="rect">
@@ -5302,9 +7187,9 @@
           <a:p>
             <a:pPr algn="l"/>
             <a:r>
-              <a:rPr sz="1200" b="0">
-                <a:solidFill>
-                  <a:srgbClr val="333333"/>
+              <a:rPr sz="1200" b="0" i="0">
+                <a:solidFill>
+                  <a:srgbClr val="2A2A2A"/>
                 </a:solidFill>
               </a:rPr>
               <a:t>Bilgisayar Mühendisliği</a:t>
@@ -5320,7 +7205,7 @@
         </p:nvSpPr>
         <p:spPr>
           <a:xfrm>
-            <a:off x="5349240" y="3310128"/>
+            <a:off x="5349240" y="3282696"/>
             <a:ext cx="4343400" cy="0"/>
           </a:xfrm>
           <a:prstGeom prst="rect">
@@ -5362,7 +7247,7 @@
         </p:nvSpPr>
         <p:spPr>
           <a:xfrm>
-            <a:off x="2468880" y="3520439"/>
+            <a:off x="2468880" y="3511296"/>
             <a:ext cx="2834640" cy="320040"/>
           </a:xfrm>
           <a:prstGeom prst="rect">
@@ -5378,7 +7263,7 @@
           <a:p>
             <a:pPr algn="l"/>
             <a:r>
-              <a:rPr sz="1200" b="1">
+              <a:rPr sz="1200" b="1" i="0">
                 <a:solidFill>
                   <a:srgbClr val="0D2B55"/>
                 </a:solidFill>
@@ -5396,7 +7281,7 @@
         </p:nvSpPr>
         <p:spPr>
           <a:xfrm>
-            <a:off x="5394960" y="3520439"/>
+            <a:off x="5394960" y="3511296"/>
             <a:ext cx="4297680" cy="320040"/>
           </a:xfrm>
           <a:prstGeom prst="rect">
@@ -5412,9 +7297,9 @@
           <a:p>
             <a:pPr algn="l"/>
             <a:r>
-              <a:rPr sz="1200" b="0">
-                <a:solidFill>
-                  <a:srgbClr val="333333"/>
+              <a:rPr sz="1200" b="0" i="0">
+                <a:solidFill>
+                  <a:srgbClr val="2A2A2A"/>
                 </a:solidFill>
               </a:rPr>
               <a:t/>
@@ -5430,7 +7315,7 @@
         </p:nvSpPr>
         <p:spPr>
           <a:xfrm>
-            <a:off x="5349240" y="3858768"/>
+            <a:off x="5349240" y="3849624"/>
             <a:ext cx="4343400" cy="0"/>
           </a:xfrm>
           <a:prstGeom prst="rect">
@@ -5472,7 +7357,7 @@
         </p:nvSpPr>
         <p:spPr>
           <a:xfrm>
-            <a:off x="2468880" y="4069079"/>
+            <a:off x="2468880" y="4078224"/>
             <a:ext cx="2834640" cy="320040"/>
           </a:xfrm>
           <a:prstGeom prst="rect">
@@ -5488,7 +7373,7 @@
           <a:p>
             <a:pPr algn="l"/>
             <a:r>
-              <a:rPr sz="1200" b="1">
+              <a:rPr sz="1200" b="1" i="0">
                 <a:solidFill>
                   <a:srgbClr val="0D2B55"/>
                 </a:solidFill>
@@ -5506,7 +7391,7 @@
         </p:nvSpPr>
         <p:spPr>
           <a:xfrm>
-            <a:off x="5394960" y="4069079"/>
+            <a:off x="5394960" y="4078224"/>
             <a:ext cx="4297680" cy="320040"/>
           </a:xfrm>
           <a:prstGeom prst="rect">
@@ -5522,9 +7407,9 @@
           <a:p>
             <a:pPr algn="l"/>
             <a:r>
-              <a:rPr sz="1200" b="0">
-                <a:solidFill>
-                  <a:srgbClr val="333333"/>
+              <a:rPr sz="1200" b="0" i="0">
+                <a:solidFill>
+                  <a:srgbClr val="2A2A2A"/>
                 </a:solidFill>
               </a:rPr>
               <a:t/>
@@ -5540,7 +7425,7 @@
         </p:nvSpPr>
         <p:spPr>
           <a:xfrm>
-            <a:off x="5349240" y="4407407"/>
+            <a:off x="5349240" y="4416552"/>
             <a:ext cx="4343400" cy="0"/>
           </a:xfrm>
           <a:prstGeom prst="rect">
@@ -5582,7 +7467,7 @@
         </p:nvSpPr>
         <p:spPr>
           <a:xfrm>
-            <a:off x="2468880" y="4617720"/>
+            <a:off x="2468880" y="4645152"/>
             <a:ext cx="2834640" cy="320040"/>
           </a:xfrm>
           <a:prstGeom prst="rect">
@@ -5598,7 +7483,7 @@
           <a:p>
             <a:pPr algn="l"/>
             <a:r>
-              <a:rPr sz="1200" b="1">
+              <a:rPr sz="1200" b="1" i="0">
                 <a:solidFill>
                   <a:srgbClr val="0D2B55"/>
                 </a:solidFill>
@@ -5616,7 +7501,7 @@
         </p:nvSpPr>
         <p:spPr>
           <a:xfrm>
-            <a:off x="5394960" y="4617720"/>
+            <a:off x="5394960" y="4645152"/>
             <a:ext cx="4297680" cy="320040"/>
           </a:xfrm>
           <a:prstGeom prst="rect">
@@ -5632,9 +7517,9 @@
           <a:p>
             <a:pPr algn="l"/>
             <a:r>
-              <a:rPr sz="1200" b="0">
-                <a:solidFill>
-                  <a:srgbClr val="333333"/>
+              <a:rPr sz="1200" b="0" i="0">
+                <a:solidFill>
+                  <a:srgbClr val="2A2A2A"/>
                 </a:solidFill>
               </a:rPr>
               <a:t>Dönem Başlangıç Sunumu</a:t>
@@ -5650,7 +7535,7 @@
         </p:nvSpPr>
         <p:spPr>
           <a:xfrm>
-            <a:off x="5349240" y="4956048"/>
+            <a:off x="5349240" y="4983480"/>
             <a:ext cx="4343400" cy="0"/>
           </a:xfrm>
           <a:prstGeom prst="rect">
@@ -5692,7 +7577,7 @@
         </p:nvSpPr>
         <p:spPr>
           <a:xfrm>
-            <a:off x="2468880" y="5394960"/>
+            <a:off x="2468880" y="5440680"/>
             <a:ext cx="2926080" cy="347472"/>
           </a:xfrm>
           <a:prstGeom prst="rect">
@@ -5708,7 +7593,7 @@
           <a:p>
             <a:pPr algn="l"/>
             <a:r>
-              <a:rPr sz="1300" b="1">
+              <a:rPr sz="1300" b="1" i="0">
                 <a:solidFill>
                   <a:srgbClr val="0D2B55"/>
                 </a:solidFill>
@@ -5726,7 +7611,7 @@
         </p:nvSpPr>
         <p:spPr>
           <a:xfrm>
-            <a:off x="3246120" y="5742432"/>
+            <a:off x="3246120" y="5788152"/>
             <a:ext cx="6080760" cy="0"/>
           </a:xfrm>
           <a:prstGeom prst="rect">
@@ -5734,7 +7619,7 @@
           </a:prstGeom>
           <a:ln w="19050">
             <a:solidFill>
-              <a:srgbClr val="333333"/>
+              <a:srgbClr val="2A2A2A"/>
             </a:solidFill>
           </a:ln>
         </p:spPr>
@@ -5768,8 +7653,8 @@
         </p:nvSpPr>
         <p:spPr>
           <a:xfrm>
-            <a:off x="3246120" y="5797296"/>
-            <a:ext cx="6080760" cy="292608"/>
+            <a:off x="3246120" y="5843016"/>
+            <a:ext cx="6080760" cy="274320"/>
           </a:xfrm>
           <a:prstGeom prst="rect">
             <a:avLst/>
@@ -5784,9 +7669,9 @@
           <a:p>
             <a:pPr algn="ctr"/>
             <a:r>
-              <a:rPr sz="900" b="0">
-                <a:solidFill>
-                  <a:srgbClr val="888888"/>
+              <a:rPr sz="900" b="0" i="0">
+                <a:solidFill>
+                  <a:srgbClr val="66707A"/>
                 </a:solidFill>
               </a:rPr>
               <a:t>(Öğrenci bu alanı imzalayarak sunumun kendisine ait olduğunu onaylar.)</a:t>

</xml_diff>

<commit_message>
Update presentation files and enhance content clarity in multiple slides
</commit_message>
<xml_diff>
--- a/docs/academic/TeslimEdilecekler/Sunumlar/01_Donem_Baslangic_Sunumu.pptx
+++ b/docs/academic/TeslimEdilecekler/Sunumlar/01_Donem_Baslangic_Sunumu.pptx
@@ -3954,7 +3954,7 @@
         <p:spPr>
           <a:xfrm>
             <a:off x="365760" y="6473952"/>
-            <a:ext cx="7772400" cy="292608"/>
+            <a:ext cx="4206240" cy="292608"/>
           </a:xfrm>
           <a:prstGeom prst="rect">
             <a:avLst/>
@@ -3975,7 +3975,7 @@
                 </a:solidFill>
                 <a:latin typeface="Calibri"/>
               </a:rPr>
-              <a:t>AURIS  ·  Yapay Zekâ Üretimli Müzik Tespiti</a:t>
+              <a:t>AURIS · YZ Üretimli Müzik Tespiti</a:t>
             </a:r>
           </a:p>
         </p:txBody>
@@ -3988,8 +3988,8 @@
         </p:nvSpPr>
         <p:spPr>
           <a:xfrm>
-            <a:off x="5029200" y="6473952"/>
-            <a:ext cx="6793992" cy="292608"/>
+            <a:off x="4663440" y="6473952"/>
+            <a:ext cx="7159752" cy="292608"/>
           </a:xfrm>
           <a:prstGeom prst="rect">
             <a:avLst/>
@@ -5035,7 +5035,7 @@
         <p:spPr>
           <a:xfrm>
             <a:off x="365760" y="6473952"/>
-            <a:ext cx="7772400" cy="292608"/>
+            <a:ext cx="4206240" cy="292608"/>
           </a:xfrm>
           <a:prstGeom prst="rect">
             <a:avLst/>
@@ -5056,7 +5056,7 @@
                 </a:solidFill>
                 <a:latin typeface="Calibri"/>
               </a:rPr>
-              <a:t>AURIS  ·  Yapay Zekâ Üretimli Müzik Tespiti</a:t>
+              <a:t>AURIS · YZ Üretimli Müzik Tespiti</a:t>
             </a:r>
           </a:p>
         </p:txBody>
@@ -5069,8 +5069,8 @@
         </p:nvSpPr>
         <p:spPr>
           <a:xfrm>
-            <a:off x="5029200" y="6473952"/>
-            <a:ext cx="6793992" cy="292608"/>
+            <a:off x="4663440" y="6473952"/>
+            <a:ext cx="7159752" cy="292608"/>
           </a:xfrm>
           <a:prstGeom prst="rect">
             <a:avLst/>
@@ -6044,7 +6044,7 @@
         <p:spPr>
           <a:xfrm>
             <a:off x="365760" y="6473952"/>
-            <a:ext cx="7772400" cy="292608"/>
+            <a:ext cx="4206240" cy="292608"/>
           </a:xfrm>
           <a:prstGeom prst="rect">
             <a:avLst/>
@@ -6065,7 +6065,7 @@
                 </a:solidFill>
                 <a:latin typeface="Calibri"/>
               </a:rPr>
-              <a:t>AURIS  ·  Yapay Zekâ Üretimli Müzik Tespiti</a:t>
+              <a:t>AURIS · YZ Üretimli Müzik Tespiti</a:t>
             </a:r>
           </a:p>
         </p:txBody>
@@ -6078,8 +6078,8 @@
         </p:nvSpPr>
         <p:spPr>
           <a:xfrm>
-            <a:off x="5029200" y="6473952"/>
-            <a:ext cx="6793992" cy="292608"/>
+            <a:off x="4663440" y="6473952"/>
+            <a:ext cx="7159752" cy="292608"/>
           </a:xfrm>
           <a:prstGeom prst="rect">
             <a:avLst/>
@@ -7506,7 +7506,7 @@
         <p:spPr>
           <a:xfrm>
             <a:off x="365760" y="6473952"/>
-            <a:ext cx="7772400" cy="292608"/>
+            <a:ext cx="4206240" cy="292608"/>
           </a:xfrm>
           <a:prstGeom prst="rect">
             <a:avLst/>
@@ -7527,7 +7527,7 @@
                 </a:solidFill>
                 <a:latin typeface="Calibri"/>
               </a:rPr>
-              <a:t>AURIS  ·  Yapay Zekâ Üretimli Müzik Tespiti</a:t>
+              <a:t>AURIS · YZ Üretimli Müzik Tespiti</a:t>
             </a:r>
           </a:p>
         </p:txBody>
@@ -7540,8 +7540,8 @@
         </p:nvSpPr>
         <p:spPr>
           <a:xfrm>
-            <a:off x="5029200" y="6473952"/>
-            <a:ext cx="6793992" cy="292608"/>
+            <a:off x="4663440" y="6473952"/>
+            <a:ext cx="7159752" cy="292608"/>
           </a:xfrm>
           <a:prstGeom prst="rect">
             <a:avLst/>

</xml_diff>